<commit_message>
style: convert presentation deck to professional corporate light theme
</commit_message>
<xml_diff>
--- a/RecoverIQ_Razorpay_AI_Buildathon.pptx
+++ b/RecoverIQ_Razorpay_AI_Buildathon.pptx
@@ -3111,7 +3111,7 @@
             <a:avLst/>
           </a:prstGeom>
           <a:solidFill>
-            <a:srgbClr val="080C16"/>
+            <a:srgbClr val="F8FAFC"/>
           </a:solidFill>
           <a:ln>
             <a:noFill/>
@@ -3148,13 +3148,13 @@
         <p:spPr>
           <a:xfrm>
             <a:off x="0" y="0"/>
-            <a:ext cx="12191695" cy="73152"/>
+            <a:ext cx="12191695" cy="54864"/>
           </a:xfrm>
           <a:prstGeom prst="rect">
             <a:avLst/>
           </a:prstGeom>
           <a:solidFill>
-            <a:srgbClr val="00E5FF"/>
+            <a:srgbClr val="0284C7"/>
           </a:solidFill>
           <a:ln>
             <a:noFill/>
@@ -3197,11 +3197,11 @@
             <a:avLst/>
           </a:prstGeom>
           <a:solidFill>
-            <a:srgbClr val="10182A"/>
-          </a:solidFill>
-          <a:ln w="15240">
+            <a:srgbClr val="FFFFFF"/>
+          </a:solidFill>
+          <a:ln w="12700">
             <a:solidFill>
-              <a:srgbClr val="21304D"/>
+              <a:srgbClr val="E2E8F0"/>
             </a:solidFill>
           </a:ln>
         </p:spPr>
@@ -3242,7 +3242,7 @@
             <a:avLst/>
           </a:prstGeom>
           <a:solidFill>
-            <a:srgbClr val="00E5FF"/>
+            <a:srgbClr val="0284C7"/>
           </a:solidFill>
           <a:ln>
             <a:noFill/>
@@ -3285,11 +3285,11 @@
             <a:avLst/>
           </a:prstGeom>
           <a:solidFill>
-            <a:srgbClr val="0E223D"/>
+            <a:srgbClr val="E0F2FE"/>
           </a:solidFill>
           <a:ln w="12700">
             <a:solidFill>
-              <a:srgbClr val="00E5FF"/>
+              <a:srgbClr val="0284C7"/>
             </a:solidFill>
           </a:ln>
         </p:spPr>
@@ -3314,7 +3314,7 @@
             <a:pPr algn="ctr">
               <a:defRPr sz="950" b="1">
                 <a:solidFill>
-                  <a:srgbClr val="00E5FF"/>
+                  <a:srgbClr val="0284C7"/>
                 </a:solidFill>
                 <a:latin typeface="Consolas"/>
               </a:defRPr>
@@ -3350,7 +3350,7 @@
             <a:pPr>
               <a:defRPr sz="5600" b="1">
                 <a:solidFill>
-                  <a:srgbClr val="FFFFFF"/>
+                  <a:srgbClr val="0F172A"/>
                 </a:solidFill>
                 <a:latin typeface="Segoe UI"/>
               </a:defRPr>
@@ -3386,13 +3386,13 @@
             <a:pPr>
               <a:defRPr sz="2200" b="1">
                 <a:solidFill>
-                  <a:srgbClr val="00E5FF"/>
+                  <a:srgbClr val="0284C7"/>
                 </a:solidFill>
                 <a:latin typeface="Segoe UI"/>
               </a:defRPr>
             </a:pPr>
             <a:r>
-              <a:t>Autonomous AI Revenue Recovery Opportunity Engine</a:t>
+              <a:t>AI Revenue Recovery Opportunity Engine</a:t>
             </a:r>
           </a:p>
         </p:txBody>
@@ -3422,13 +3422,13 @@
             <a:pPr>
               <a:defRPr sz="1600">
                 <a:solidFill>
-                  <a:srgbClr val="94A3B8"/>
+                  <a:srgbClr val="475569"/>
                 </a:solidFill>
                 <a:latin typeface="Segoe UI"/>
               </a:defRPr>
             </a:pPr>
             <a:r>
-              <a:t>Core Paradigm: "Detect. Predict. Prioritize. Recover — safely."</a:t>
+              <a:t>Detect. Predict. Prioritize. Recover — safely.</a:t>
             </a:r>
           </a:p>
         </p:txBody>
@@ -3448,11 +3448,11 @@
             <a:avLst/>
           </a:prstGeom>
           <a:solidFill>
-            <a:srgbClr val="0C1220"/>
-          </a:solidFill>
-          <a:ln w="15240">
+            <a:srgbClr val="F8FAFC"/>
+          </a:solidFill>
+          <a:ln w="12700">
             <a:solidFill>
-              <a:srgbClr val="1C2A44"/>
+              <a:srgbClr val="E2E8F0"/>
             </a:solidFill>
           </a:ln>
         </p:spPr>
@@ -3493,7 +3493,7 @@
             <a:avLst/>
           </a:prstGeom>
           <a:solidFill>
-            <a:srgbClr val="3395FF"/>
+            <a:srgbClr val="0284C7"/>
           </a:solidFill>
           <a:ln>
             <a:noFill/>
@@ -3549,26 +3549,26 @@
               </a:spcAft>
               <a:defRPr sz="900" b="1">
                 <a:solidFill>
-                  <a:srgbClr val="3395FF"/>
+                  <a:srgbClr val="0284C7"/>
                 </a:solidFill>
                 <a:latin typeface="Consolas"/>
               </a:defRPr>
             </a:pPr>
             <a:r>
-              <a:t>INFERENCE ENGINE</a:t>
-            </a:r>
-          </a:p>
-          <a:p>
-            <a:pPr>
-              <a:defRPr sz="1100">
-                <a:solidFill>
-                  <a:srgbClr val="FFFFFF"/>
+              <a:t>INFERENCE</a:t>
+            </a:r>
+          </a:p>
+          <a:p>
+            <a:pPr>
+              <a:defRPr sz="1100" b="1">
+                <a:solidFill>
+                  <a:srgbClr val="0F172A"/>
                 </a:solidFill>
                 <a:latin typeface="Segoe UI"/>
               </a:defRPr>
             </a:pPr>
             <a:r>
-              <a:t>Gradient Boosted Trees (Calibrated Deciles)</a:t>
+              <a:t>Calibrated GBDT Deciles</a:t>
             </a:r>
           </a:p>
         </p:txBody>
@@ -3588,11 +3588,11 @@
             <a:avLst/>
           </a:prstGeom>
           <a:solidFill>
-            <a:srgbClr val="0C1220"/>
-          </a:solidFill>
-          <a:ln w="15240">
+            <a:srgbClr val="F8FAFC"/>
+          </a:solidFill>
+          <a:ln w="12700">
             <a:solidFill>
-              <a:srgbClr val="1C2A44"/>
+              <a:srgbClr val="E2E8F0"/>
             </a:solidFill>
           </a:ln>
         </p:spPr>
@@ -3633,7 +3633,7 @@
             <a:avLst/>
           </a:prstGeom>
           <a:solidFill>
-            <a:srgbClr val="6366F1"/>
+            <a:srgbClr val="0F172A"/>
           </a:solidFill>
           <a:ln>
             <a:noFill/>
@@ -3689,26 +3689,26 @@
               </a:spcAft>
               <a:defRPr sz="900" b="1">
                 <a:solidFill>
-                  <a:srgbClr val="6366F1"/>
+                  <a:srgbClr val="0F172A"/>
                 </a:solidFill>
                 <a:latin typeface="Consolas"/>
               </a:defRPr>
             </a:pPr>
             <a:r>
-              <a:t>OPTIMIZATION CORE</a:t>
-            </a:r>
-          </a:p>
-          <a:p>
-            <a:pPr>
-              <a:defRPr sz="1100">
-                <a:solidFill>
-                  <a:srgbClr val="FFFFFF"/>
+              <a:t>OPTIMIZATION</a:t>
+            </a:r>
+          </a:p>
+          <a:p>
+            <a:pPr>
+              <a:defRPr sz="1100" b="1">
+                <a:solidFill>
+                  <a:srgbClr val="0F172A"/>
                 </a:solidFill>
                 <a:latin typeface="Segoe UI"/>
               </a:defRPr>
             </a:pPr>
             <a:r>
-              <a:t>0/1 Knapsack Dynamic Programming</a:t>
+              <a:t>0/1 Knapsack DP</a:t>
             </a:r>
           </a:p>
         </p:txBody>
@@ -3728,11 +3728,11 @@
             <a:avLst/>
           </a:prstGeom>
           <a:solidFill>
-            <a:srgbClr val="0C1220"/>
-          </a:solidFill>
-          <a:ln w="15240">
+            <a:srgbClr val="F8FAFC"/>
+          </a:solidFill>
+          <a:ln w="12700">
             <a:solidFill>
-              <a:srgbClr val="1C2A44"/>
+              <a:srgbClr val="E2E8F0"/>
             </a:solidFill>
           </a:ln>
         </p:spPr>
@@ -3773,7 +3773,7 @@
             <a:avLst/>
           </a:prstGeom>
           <a:solidFill>
-            <a:srgbClr val="10B981"/>
+            <a:srgbClr val="059669"/>
           </a:solidFill>
           <a:ln>
             <a:noFill/>
@@ -3829,26 +3829,26 @@
               </a:spcAft>
               <a:defRPr sz="900" b="1">
                 <a:solidFill>
-                  <a:srgbClr val="10B981"/>
+                  <a:srgbClr val="059669"/>
                 </a:solidFill>
                 <a:latin typeface="Consolas"/>
               </a:defRPr>
             </a:pPr>
             <a:r>
-              <a:t>SAFETY RAILS</a:t>
-            </a:r>
-          </a:p>
-          <a:p>
-            <a:pPr>
-              <a:defRPr sz="1100">
-                <a:solidFill>
-                  <a:srgbClr val="FFFFFF"/>
+              <a:t>SAFETY</a:t>
+            </a:r>
+          </a:p>
+          <a:p>
+            <a:pPr>
+              <a:defRPr sz="1100" b="1">
+                <a:solidFill>
+                  <a:srgbClr val="0F172A"/>
                 </a:solidFill>
                 <a:latin typeface="Segoe UI"/>
               </a:defRPr>
             </a:pPr>
             <a:r>
-              <a:t>Deterministic Spend &amp; Cooldown Firewall</a:t>
+              <a:t>Deterministic Bounds</a:t>
             </a:r>
           </a:p>
         </p:txBody>
@@ -3868,11 +3868,11 @@
             <a:avLst/>
           </a:prstGeom>
           <a:solidFill>
-            <a:srgbClr val="0C1220"/>
-          </a:solidFill>
-          <a:ln w="15240">
+            <a:srgbClr val="F8FAFC"/>
+          </a:solidFill>
+          <a:ln w="12700">
             <a:solidFill>
-              <a:srgbClr val="1C2A44"/>
+              <a:srgbClr val="E2E8F0"/>
             </a:solidFill>
           </a:ln>
         </p:spPr>
@@ -3913,7 +3913,7 @@
             <a:avLst/>
           </a:prstGeom>
           <a:solidFill>
-            <a:srgbClr val="00E5FF"/>
+            <a:srgbClr val="0066FF"/>
           </a:solidFill>
           <a:ln>
             <a:noFill/>
@@ -3969,7 +3969,7 @@
               </a:spcAft>
               <a:defRPr sz="900" b="1">
                 <a:solidFill>
-                  <a:srgbClr val="00E5FF"/>
+                  <a:srgbClr val="0066FF"/>
                 </a:solidFill>
                 <a:latin typeface="Consolas"/>
               </a:defRPr>
@@ -3980,15 +3980,15 @@
           </a:p>
           <a:p>
             <a:pPr>
-              <a:defRPr sz="1100">
-                <a:solidFill>
-                  <a:srgbClr val="FFFFFF"/>
+              <a:defRPr sz="1100" b="1">
+                <a:solidFill>
+                  <a:srgbClr val="0F172A"/>
                 </a:solidFill>
                 <a:latin typeface="Segoe UI"/>
               </a:defRPr>
             </a:pPr>
             <a:r>
-              <a:t>Native Razorpay Test Mode &amp; Webhooks</a:t>
+              <a:t>Razorpay Test Mode</a:t>
             </a:r>
           </a:p>
         </p:txBody>
@@ -4018,13 +4018,13 @@
             <a:pPr>
               <a:defRPr sz="1050">
                 <a:solidFill>
-                  <a:srgbClr val="7891B4"/>
-                </a:solidFill>
-                <a:latin typeface="Consolas"/>
-              </a:defRPr>
-            </a:pPr>
-            <a:r>
-              <a:t>Architected &amp; Presented by: R Yaswanth Raju  |  Platform: FastAPI, SQLite, scikit-learn, Razorpay SDK</a:t>
+                  <a:srgbClr val="64748B"/>
+                </a:solidFill>
+                <a:latin typeface="Segoe UI"/>
+              </a:defRPr>
+            </a:pPr>
+            <a:r>
+              <a:t>Presenter: R Yaswanth Raju  |  Platform: FastAPI, SQLite, scikit-learn, Razorpay SDK</a:t>
             </a:r>
           </a:p>
         </p:txBody>
@@ -4054,13 +4054,13 @@
             <a:pPr>
               <a:defRPr sz="900">
                 <a:solidFill>
-                  <a:srgbClr val="5A6E8C"/>
-                </a:solidFill>
-                <a:latin typeface="Consolas"/>
-              </a:defRPr>
-            </a:pPr>
-            <a:r>
-              <a:t>RecoverIQ  //  AI Revenue Recovery Opportunity Engine  |  Razorpay AI Buildathon (Track 3)  |  Slide 1 of 9</a:t>
+                  <a:srgbClr val="64748B"/>
+                </a:solidFill>
+                <a:latin typeface="Segoe UI"/>
+              </a:defRPr>
+            </a:pPr>
+            <a:r>
+              <a:t>RecoverIQ  |  AI Revenue Recovery Engine  |  Razorpay AI Buildathon  |  Slide 1 of 9</a:t>
             </a:r>
           </a:p>
         </p:txBody>
@@ -4098,7 +4098,7 @@
             <a:avLst/>
           </a:prstGeom>
           <a:solidFill>
-            <a:srgbClr val="080C16"/>
+            <a:srgbClr val="F8FAFC"/>
           </a:solidFill>
           <a:ln>
             <a:noFill/>
@@ -4135,13 +4135,13 @@
         <p:spPr>
           <a:xfrm>
             <a:off x="0" y="0"/>
-            <a:ext cx="12191695" cy="73152"/>
+            <a:ext cx="12191695" cy="54864"/>
           </a:xfrm>
           <a:prstGeom prst="rect">
             <a:avLst/>
           </a:prstGeom>
           <a:solidFill>
-            <a:srgbClr val="00E5FF"/>
+            <a:srgbClr val="0284C7"/>
           </a:solidFill>
           <a:ln>
             <a:noFill/>
@@ -4178,17 +4178,17 @@
         <p:spPr>
           <a:xfrm>
             <a:off x="731520" y="384048"/>
-            <a:ext cx="1778508" cy="292608"/>
+            <a:ext cx="1312164" cy="292608"/>
           </a:xfrm>
           <a:prstGeom prst="roundRect">
             <a:avLst/>
           </a:prstGeom>
           <a:solidFill>
-            <a:srgbClr val="102036"/>
+            <a:srgbClr val="E0F2FE"/>
           </a:solidFill>
           <a:ln w="12700">
             <a:solidFill>
-              <a:srgbClr val="00E5FF"/>
+              <a:srgbClr val="0284C7"/>
             </a:solidFill>
           </a:ln>
         </p:spPr>
@@ -4213,13 +4213,13 @@
             <a:pPr algn="ctr">
               <a:defRPr sz="950" b="1">
                 <a:solidFill>
-                  <a:srgbClr val="00E5FF"/>
+                  <a:srgbClr val="0284C7"/>
                 </a:solidFill>
                 <a:latin typeface="Consolas"/>
               </a:defRPr>
             </a:pPr>
             <a:r>
-              <a:t>DIAGNOSTIC MATRIX</a:t>
+              <a:t>THE PROBLEM</a:t>
             </a:r>
           </a:p>
         </p:txBody>
@@ -4249,7 +4249,7 @@
             <a:pPr>
               <a:defRPr sz="2300" b="1">
                 <a:solidFill>
-                  <a:srgbClr val="FFFFFF"/>
+                  <a:srgbClr val="0F172A"/>
                 </a:solidFill>
                 <a:latin typeface="Segoe UI"/>
               </a:defRPr>
@@ -4285,13 +4285,13 @@
             <a:pPr>
               <a:defRPr sz="1300">
                 <a:solidFill>
-                  <a:srgbClr val="94A3B8"/>
+                  <a:srgbClr val="475569"/>
                 </a:solidFill>
                 <a:latin typeface="Segoe UI"/>
               </a:defRPr>
             </a:pPr>
             <a:r>
-              <a:t>Merchants lose revenue across four distinct channels, and not every recoverable rupee is worth equal effort to chase.</a:t>
+              <a:t>Merchants lose revenue across four distinct channels. Not every recoverable rupee is worth equal effort to chase.</a:t>
             </a:r>
           </a:p>
         </p:txBody>
@@ -4311,11 +4311,11 @@
             <a:avLst/>
           </a:prstGeom>
           <a:solidFill>
-            <a:srgbClr val="10182A"/>
-          </a:solidFill>
-          <a:ln w="15240">
+            <a:srgbClr val="FFFFFF"/>
+          </a:solidFill>
+          <a:ln w="12700">
             <a:solidFill>
-              <a:srgbClr val="21304D"/>
+              <a:srgbClr val="E2E8F0"/>
             </a:solidFill>
           </a:ln>
         </p:spPr>
@@ -4356,7 +4356,7 @@
             <a:avLst/>
           </a:prstGeom>
           <a:solidFill>
-            <a:srgbClr val="F43F5E"/>
+            <a:srgbClr val="E11D48"/>
           </a:solidFill>
           <a:ln>
             <a:noFill/>
@@ -4412,7 +4412,7 @@
               </a:spcAft>
               <a:defRPr sz="950" b="1">
                 <a:solidFill>
-                  <a:srgbClr val="F43F5E"/>
+                  <a:srgbClr val="E11D48"/>
                 </a:solidFill>
                 <a:latin typeface="Consolas"/>
               </a:defRPr>
@@ -4428,7 +4428,7 @@
               </a:spcAft>
               <a:defRPr sz="1600" b="1">
                 <a:solidFill>
-                  <a:srgbClr val="FFFFFF"/>
+                  <a:srgbClr val="0F172A"/>
                 </a:solidFill>
                 <a:latin typeface="Segoe UI"/>
               </a:defRPr>
@@ -4444,42 +4444,13 @@
               </a:spcAft>
               <a:defRPr sz="1200">
                 <a:solidFill>
-                  <a:srgbClr val="94A3B8"/>
+                  <a:srgbClr val="475569"/>
                 </a:solidFill>
                 <a:latin typeface="Segoe UI"/>
               </a:defRPr>
             </a:pPr>
             <a:r>
-              <a:t>Card declines, issuer bank network timeouts, 3DS authentication drops, and insufficient account balance.</a:t>
-            </a:r>
-          </a:p>
-          <a:p>
-            <a:pPr>
-              <a:spcAft>
-                <a:spcPts val="400"/>
-              </a:spcAft>
-              <a:defRPr sz="1000" b="1">
-                <a:solidFill>
-                  <a:srgbClr val="F43F5E"/>
-                </a:solidFill>
-                <a:latin typeface="Consolas"/>
-              </a:defRPr>
-            </a:pPr>
-            <a:r>
-              <a:t>CORE RISK:</a:t>
-            </a:r>
-          </a:p>
-          <a:p>
-            <a:pPr>
-              <a:defRPr sz="1150">
-                <a:solidFill>
-                  <a:srgbClr val="BAE6FD"/>
-                </a:solidFill>
-                <a:latin typeface="Segoe UI"/>
-              </a:defRPr>
-            </a:pPr>
-            <a:r>
-              <a:t>Naive retry storms trigger merchant payment processor throttling and aggravate customers.</a:t>
+              <a:t>Card declines, issuer bank timeouts, 3DS drops, and insufficient funds.</a:t>
             </a:r>
           </a:p>
         </p:txBody>
@@ -4492,18 +4463,18 @@
         </p:nvSpPr>
         <p:spPr>
           <a:xfrm>
-            <a:off x="3456432" y="1828800"/>
-            <a:ext cx="2542032" cy="4343400"/>
+            <a:off x="868680" y="4754880"/>
+            <a:ext cx="2267712" cy="1188720"/>
           </a:xfrm>
           <a:prstGeom prst="roundRect">
             <a:avLst/>
           </a:prstGeom>
           <a:solidFill>
-            <a:srgbClr val="10182A"/>
-          </a:solidFill>
-          <a:ln w="15240">
+            <a:srgbClr val="FEE2E2"/>
+          </a:solidFill>
+          <a:ln w="6350">
             <a:solidFill>
-              <a:srgbClr val="21304D"/>
+              <a:srgbClr val="E11D48"/>
             </a:solidFill>
           </a:ln>
         </p:spPr>
@@ -4522,10 +4493,24 @@
           </a:fontRef>
         </p:style>
         <p:txBody>
-          <a:bodyPr rtlCol="0" anchor="ctr"/>
-          <a:lstStyle/>
-          <a:p>
-            <a:pPr algn="ctr"/>
+          <a:bodyPr rtlCol="0" anchor="ctr" wrap="square"/>
+          <a:lstStyle/>
+          <a:p>
+            <a:pPr algn="ctr">
+              <a:defRPr sz="1100" b="1">
+                <a:solidFill>
+                  <a:srgbClr val="E11D48"/>
+                </a:solidFill>
+                <a:latin typeface="Segoe UI"/>
+              </a:defRPr>
+            </a:pPr>
+            <a:r>
+              <a:t>CORE RISK:</a:t>
+            </a:r>
+            <a:br/>
+            <a:r>
+              <a:t>Naive retry storms trigger gateway penalties and spam customers.</a:t>
+            </a:r>
           </a:p>
         </p:txBody>
       </p:sp>
@@ -4538,16 +4523,18 @@
         <p:spPr>
           <a:xfrm>
             <a:off x="3456432" y="1828800"/>
-            <a:ext cx="2542032" cy="54864"/>
+            <a:ext cx="2542032" cy="4343400"/>
           </a:xfrm>
           <a:prstGeom prst="roundRect">
             <a:avLst/>
           </a:prstGeom>
           <a:solidFill>
-            <a:srgbClr val="F59E0B"/>
-          </a:solidFill>
-          <a:ln>
-            <a:noFill/>
+            <a:srgbClr val="FFFFFF"/>
+          </a:solidFill>
+          <a:ln w="12700">
+            <a:solidFill>
+              <a:srgbClr val="E2E8F0"/>
+            </a:solidFill>
           </a:ln>
         </p:spPr>
         <p:style>
@@ -4574,125 +4561,23 @@
       </p:sp>
       <p:sp>
         <p:nvSpPr>
-          <p:cNvPr id="12" name="TextBox 11"/>
-          <p:cNvSpPr txBox="1"/>
-          <p:nvPr/>
-        </p:nvSpPr>
-        <p:spPr>
-          <a:xfrm>
-            <a:off x="3639312" y="1965960"/>
-            <a:ext cx="2176272" cy="4069080"/>
-          </a:xfrm>
-          <a:prstGeom prst="rect">
-            <a:avLst/>
-          </a:prstGeom>
-          <a:noFill/>
-        </p:spPr>
-        <p:txBody>
-          <a:bodyPr wrap="square">
-            <a:spAutoFit/>
-          </a:bodyPr>
-          <a:lstStyle/>
-          <a:p>
-            <a:pPr>
-              <a:spcAft>
-                <a:spcPts val="800"/>
-              </a:spcAft>
-              <a:defRPr sz="950" b="1">
-                <a:solidFill>
-                  <a:srgbClr val="F59E0B"/>
-                </a:solidFill>
-                <a:latin typeface="Consolas"/>
-              </a:defRPr>
-            </a:pPr>
-            <a:r>
-              <a:t>02 / PARTIAL PAYMENTS</a:t>
-            </a:r>
-          </a:p>
-          <a:p>
-            <a:pPr>
-              <a:spcAft>
-                <a:spcPts val="1000"/>
-              </a:spcAft>
-              <a:defRPr sz="1600" b="1">
-                <a:solidFill>
-                  <a:srgbClr val="FFFFFF"/>
-                </a:solidFill>
-                <a:latin typeface="Segoe UI"/>
-              </a:defRPr>
-            </a:pPr>
-            <a:r>
-              <a:t>Abandoned Balances</a:t>
-            </a:r>
-          </a:p>
-          <a:p>
-            <a:pPr>
-              <a:spcAft>
-                <a:spcPts val="1400"/>
-              </a:spcAft>
-              <a:defRPr sz="1200">
-                <a:solidFill>
-                  <a:srgbClr val="94A3B8"/>
-                </a:solidFill>
-                <a:latin typeface="Segoe UI"/>
-              </a:defRPr>
-            </a:pPr>
-            <a:r>
-              <a:t>Token advances or booking deposits paid, but subsequent milestone payments neglected.</a:t>
-            </a:r>
-          </a:p>
-          <a:p>
-            <a:pPr>
-              <a:spcAft>
-                <a:spcPts val="400"/>
-              </a:spcAft>
-              <a:defRPr sz="1000" b="1">
-                <a:solidFill>
-                  <a:srgbClr val="F59E0B"/>
-                </a:solidFill>
-                <a:latin typeface="Consolas"/>
-              </a:defRPr>
-            </a:pPr>
-            <a:r>
-              <a:t>CORE RISK:</a:t>
-            </a:r>
-          </a:p>
-          <a:p>
-            <a:pPr>
-              <a:defRPr sz="1150">
-                <a:solidFill>
-                  <a:srgbClr val="BAE6FD"/>
-                </a:solidFill>
-                <a:latin typeface="Segoe UI"/>
-              </a:defRPr>
-            </a:pPr>
-            <a:r>
-              <a:t>Manual merchant chasing has a 70% drop-off rate without automated multi-channel links.</a:t>
-            </a:r>
-          </a:p>
-        </p:txBody>
-      </p:sp>
-      <p:sp>
-        <p:nvSpPr>
-          <p:cNvPr id="13" name="Rounded Rectangle 12"/>
+          <p:cNvPr id="12" name="Rounded Rectangle 11"/>
           <p:cNvSpPr/>
           <p:nvPr/>
         </p:nvSpPr>
         <p:spPr>
           <a:xfrm>
-            <a:off x="6181344" y="1828800"/>
-            <a:ext cx="2542032" cy="4343400"/>
+            <a:off x="3456432" y="1828800"/>
+            <a:ext cx="2542032" cy="54864"/>
           </a:xfrm>
           <a:prstGeom prst="roundRect">
             <a:avLst/>
           </a:prstGeom>
           <a:solidFill>
-            <a:srgbClr val="10182A"/>
-          </a:solidFill>
-          <a:ln w="15240">
-            <a:solidFill>
-              <a:srgbClr val="21304D"/>
-            </a:solidFill>
+            <a:srgbClr val="D97706"/>
+          </a:solidFill>
+          <a:ln>
+            <a:noFill/>
           </a:ln>
         </p:spPr>
         <p:style>
@@ -4719,23 +4604,96 @@
       </p:sp>
       <p:sp>
         <p:nvSpPr>
+          <p:cNvPr id="13" name="TextBox 12"/>
+          <p:cNvSpPr txBox="1"/>
+          <p:nvPr/>
+        </p:nvSpPr>
+        <p:spPr>
+          <a:xfrm>
+            <a:off x="3639312" y="1965960"/>
+            <a:ext cx="2176272" cy="4069080"/>
+          </a:xfrm>
+          <a:prstGeom prst="rect">
+            <a:avLst/>
+          </a:prstGeom>
+          <a:noFill/>
+        </p:spPr>
+        <p:txBody>
+          <a:bodyPr wrap="square">
+            <a:spAutoFit/>
+          </a:bodyPr>
+          <a:lstStyle/>
+          <a:p>
+            <a:pPr>
+              <a:spcAft>
+                <a:spcPts val="800"/>
+              </a:spcAft>
+              <a:defRPr sz="950" b="1">
+                <a:solidFill>
+                  <a:srgbClr val="D97706"/>
+                </a:solidFill>
+                <a:latin typeface="Consolas"/>
+              </a:defRPr>
+            </a:pPr>
+            <a:r>
+              <a:t>02 / PARTIAL PAYMENTS</a:t>
+            </a:r>
+          </a:p>
+          <a:p>
+            <a:pPr>
+              <a:spcAft>
+                <a:spcPts val="1000"/>
+              </a:spcAft>
+              <a:defRPr sz="1600" b="1">
+                <a:solidFill>
+                  <a:srgbClr val="0F172A"/>
+                </a:solidFill>
+                <a:latin typeface="Segoe UI"/>
+              </a:defRPr>
+            </a:pPr>
+            <a:r>
+              <a:t>Abandoned Balances</a:t>
+            </a:r>
+          </a:p>
+          <a:p>
+            <a:pPr>
+              <a:spcAft>
+                <a:spcPts val="1400"/>
+              </a:spcAft>
+              <a:defRPr sz="1200">
+                <a:solidFill>
+                  <a:srgbClr val="475569"/>
+                </a:solidFill>
+                <a:latin typeface="Segoe UI"/>
+              </a:defRPr>
+            </a:pPr>
+            <a:r>
+              <a:t>Token advances paid, but subsequent milestone installments neglected.</a:t>
+            </a:r>
+          </a:p>
+        </p:txBody>
+      </p:sp>
+      <p:sp>
+        <p:nvSpPr>
           <p:cNvPr id="14" name="Rounded Rectangle 13"/>
           <p:cNvSpPr/>
           <p:nvPr/>
         </p:nvSpPr>
         <p:spPr>
           <a:xfrm>
-            <a:off x="6181344" y="1828800"/>
-            <a:ext cx="2542032" cy="54864"/>
+            <a:off x="3593592" y="4754880"/>
+            <a:ext cx="2267712" cy="1188720"/>
           </a:xfrm>
           <a:prstGeom prst="roundRect">
             <a:avLst/>
           </a:prstGeom>
           <a:solidFill>
-            <a:srgbClr val="3395FF"/>
-          </a:solidFill>
-          <a:ln>
-            <a:noFill/>
+            <a:srgbClr val="FEF3C7"/>
+          </a:solidFill>
+          <a:ln w="6350">
+            <a:solidFill>
+              <a:srgbClr val="D97706"/>
+            </a:solidFill>
           </a:ln>
         </p:spPr>
         <p:style>
@@ -4753,133 +4711,47 @@
           </a:fontRef>
         </p:style>
         <p:txBody>
-          <a:bodyPr rtlCol="0" anchor="ctr"/>
-          <a:lstStyle/>
-          <a:p>
-            <a:pPr algn="ctr"/>
-          </a:p>
-        </p:txBody>
-      </p:sp>
-      <p:sp>
-        <p:nvSpPr>
-          <p:cNvPr id="15" name="TextBox 14"/>
-          <p:cNvSpPr txBox="1"/>
-          <p:nvPr/>
-        </p:nvSpPr>
-        <p:spPr>
-          <a:xfrm>
-            <a:off x="6364224" y="1965960"/>
-            <a:ext cx="2176272" cy="4069080"/>
-          </a:xfrm>
-          <a:prstGeom prst="rect">
-            <a:avLst/>
-          </a:prstGeom>
-          <a:noFill/>
-        </p:spPr>
-        <p:txBody>
-          <a:bodyPr wrap="square">
-            <a:spAutoFit/>
-          </a:bodyPr>
-          <a:lstStyle/>
-          <a:p>
-            <a:pPr>
-              <a:spcAft>
-                <a:spcPts val="800"/>
-              </a:spcAft>
-              <a:defRPr sz="950" b="1">
-                <a:solidFill>
-                  <a:srgbClr val="3395FF"/>
-                </a:solidFill>
-                <a:latin typeface="Consolas"/>
-              </a:defRPr>
-            </a:pPr>
-            <a:r>
-              <a:t>03 / OVERDUE INVOICES</a:t>
-            </a:r>
-          </a:p>
-          <a:p>
-            <a:pPr>
-              <a:spcAft>
-                <a:spcPts val="1000"/>
-              </a:spcAft>
-              <a:defRPr sz="1600" b="1">
-                <a:solidFill>
-                  <a:srgbClr val="FFFFFF"/>
+          <a:bodyPr rtlCol="0" anchor="ctr" wrap="square"/>
+          <a:lstStyle/>
+          <a:p>
+            <a:pPr algn="ctr">
+              <a:defRPr sz="1100" b="1">
+                <a:solidFill>
+                  <a:srgbClr val="D97706"/>
                 </a:solidFill>
                 <a:latin typeface="Segoe UI"/>
               </a:defRPr>
             </a:pPr>
             <a:r>
-              <a:t>B2B Accounts Receivable</a:t>
-            </a:r>
-          </a:p>
-          <a:p>
-            <a:pPr>
-              <a:spcAft>
-                <a:spcPts val="1400"/>
-              </a:spcAft>
-              <a:defRPr sz="1200">
-                <a:solidFill>
-                  <a:srgbClr val="94A3B8"/>
-                </a:solidFill>
-                <a:latin typeface="Segoe UI"/>
-              </a:defRPr>
-            </a:pPr>
-            <a:r>
-              <a:t>Commercial B2B invoices slipping past 30/60/90 contractual net terms with zero real-time dunning.</a:t>
-            </a:r>
-          </a:p>
-          <a:p>
-            <a:pPr>
-              <a:spcAft>
-                <a:spcPts val="400"/>
-              </a:spcAft>
-              <a:defRPr sz="1000" b="1">
-                <a:solidFill>
-                  <a:srgbClr val="3395FF"/>
-                </a:solidFill>
-                <a:latin typeface="Consolas"/>
-              </a:defRPr>
-            </a:pPr>
-            <a:r>
               <a:t>CORE RISK:</a:t>
             </a:r>
-          </a:p>
-          <a:p>
-            <a:pPr>
-              <a:defRPr sz="1150">
-                <a:solidFill>
-                  <a:srgbClr val="BAE6FD"/>
-                </a:solidFill>
-                <a:latin typeface="Segoe UI"/>
-              </a:defRPr>
-            </a:pPr>
-            <a:r>
-              <a:t>Large balance exposure locked in offline receivables without payment rail automation.</a:t>
-            </a:r>
-          </a:p>
-        </p:txBody>
-      </p:sp>
-      <p:sp>
-        <p:nvSpPr>
-          <p:cNvPr id="16" name="Rounded Rectangle 15"/>
+            <a:br/>
+            <a:r>
+              <a:t>Manual merchant chasing has a 70% drop-off rate.</a:t>
+            </a:r>
+          </a:p>
+        </p:txBody>
+      </p:sp>
+      <p:sp>
+        <p:nvSpPr>
+          <p:cNvPr id="15" name="Rounded Rectangle 14"/>
           <p:cNvSpPr/>
           <p:nvPr/>
         </p:nvSpPr>
         <p:spPr>
           <a:xfrm>
-            <a:off x="8906256" y="1828800"/>
+            <a:off x="6181344" y="1828800"/>
             <a:ext cx="2542032" cy="4343400"/>
           </a:xfrm>
           <a:prstGeom prst="roundRect">
             <a:avLst/>
           </a:prstGeom>
           <a:solidFill>
-            <a:srgbClr val="10182A"/>
-          </a:solidFill>
-          <a:ln w="15240">
+            <a:srgbClr val="FFFFFF"/>
+          </a:solidFill>
+          <a:ln w="12700">
             <a:solidFill>
-              <a:srgbClr val="21304D"/>
+              <a:srgbClr val="E2E8F0"/>
             </a:solidFill>
           </a:ln>
         </p:spPr>
@@ -4907,20 +4779,20 @@
       </p:sp>
       <p:sp>
         <p:nvSpPr>
-          <p:cNvPr id="17" name="Rounded Rectangle 16"/>
+          <p:cNvPr id="16" name="Rounded Rectangle 15"/>
           <p:cNvSpPr/>
           <p:nvPr/>
         </p:nvSpPr>
         <p:spPr>
           <a:xfrm>
-            <a:off x="8906256" y="1828800"/>
+            <a:off x="6181344" y="1828800"/>
             <a:ext cx="2542032" cy="54864"/>
           </a:xfrm>
           <a:prstGeom prst="roundRect">
             <a:avLst/>
           </a:prstGeom>
           <a:solidFill>
-            <a:srgbClr val="00E5FF"/>
+            <a:srgbClr val="0F172A"/>
           </a:solidFill>
           <a:ln>
             <a:noFill/>
@@ -4950,13 +4822,13 @@
       </p:sp>
       <p:sp>
         <p:nvSpPr>
-          <p:cNvPr id="18" name="TextBox 17"/>
+          <p:cNvPr id="17" name="TextBox 16"/>
           <p:cNvSpPr txBox="1"/>
           <p:nvPr/>
         </p:nvSpPr>
         <p:spPr>
           <a:xfrm>
-            <a:off x="9089136" y="1965960"/>
+            <a:off x="6364224" y="1965960"/>
             <a:ext cx="2176272" cy="4069080"/>
           </a:xfrm>
           <a:prstGeom prst="rect">
@@ -4976,13 +4848,13 @@
               </a:spcAft>
               <a:defRPr sz="950" b="1">
                 <a:solidFill>
-                  <a:srgbClr val="00E5FF"/>
+                  <a:srgbClr val="0F172A"/>
                 </a:solidFill>
                 <a:latin typeface="Consolas"/>
               </a:defRPr>
             </a:pPr>
             <a:r>
-              <a:t>04 / REFUND MISMATCHES</a:t>
+              <a:t>03 / OVERDUE INVOICES</a:t>
             </a:r>
           </a:p>
           <a:p>
@@ -4992,13 +4864,13 @@
               </a:spcAft>
               <a:defRPr sz="1600" b="1">
                 <a:solidFill>
-                  <a:srgbClr val="FFFFFF"/>
+                  <a:srgbClr val="0F172A"/>
                 </a:solidFill>
                 <a:latin typeface="Segoe UI"/>
               </a:defRPr>
             </a:pPr>
             <a:r>
-              <a:t>Pre-Auth Captures</a:t>
+              <a:t>B2B Accounts Receivable</a:t>
             </a:r>
           </a:p>
           <a:p>
@@ -5008,49 +4880,297 @@
               </a:spcAft>
               <a:defRPr sz="1200">
                 <a:solidFill>
-                  <a:srgbClr val="94A3B8"/>
+                  <a:srgbClr val="475569"/>
                 </a:solidFill>
                 <a:latin typeface="Segoe UI"/>
               </a:defRPr>
             </a:pPr>
             <a:r>
-              <a:t>Pre-authorized gateway transactions captured on hold but unreconciled against order cancellations.</a:t>
-            </a:r>
-          </a:p>
+              <a:t>Commercial B2B invoices slipping past 30/60 net terms without dunning.</a:t>
+            </a:r>
+          </a:p>
+        </p:txBody>
+      </p:sp>
+      <p:sp>
+        <p:nvSpPr>
+          <p:cNvPr id="18" name="Rounded Rectangle 17"/>
+          <p:cNvSpPr/>
+          <p:nvPr/>
+        </p:nvSpPr>
+        <p:spPr>
+          <a:xfrm>
+            <a:off x="6318504" y="4754880"/>
+            <a:ext cx="2267712" cy="1188720"/>
+          </a:xfrm>
+          <a:prstGeom prst="roundRect">
+            <a:avLst/>
+          </a:prstGeom>
+          <a:solidFill>
+            <a:srgbClr val="E2E8F0"/>
+          </a:solidFill>
+          <a:ln w="6350">
+            <a:solidFill>
+              <a:srgbClr val="0F172A"/>
+            </a:solidFill>
+          </a:ln>
+        </p:spPr>
+        <p:style>
+          <a:lnRef idx="1">
+            <a:schemeClr val="accent1"/>
+          </a:lnRef>
+          <a:fillRef idx="3">
+            <a:schemeClr val="accent1"/>
+          </a:fillRef>
+          <a:effectRef idx="2">
+            <a:schemeClr val="accent1"/>
+          </a:effectRef>
+          <a:fontRef idx="minor">
+            <a:schemeClr val="lt1"/>
+          </a:fontRef>
+        </p:style>
+        <p:txBody>
+          <a:bodyPr rtlCol="0" anchor="ctr" wrap="square"/>
+          <a:lstStyle/>
+          <a:p>
+            <a:pPr algn="ctr">
+              <a:defRPr sz="1100" b="1">
+                <a:solidFill>
+                  <a:srgbClr val="0F172A"/>
+                </a:solidFill>
+                <a:latin typeface="Segoe UI"/>
+              </a:defRPr>
+            </a:pPr>
+            <a:r>
+              <a:t>CORE RISK:</a:t>
+            </a:r>
+            <a:br/>
+            <a:r>
+              <a:t>Working capital gets permanently locked in offline receivables.</a:t>
+            </a:r>
+          </a:p>
+        </p:txBody>
+      </p:sp>
+      <p:sp>
+        <p:nvSpPr>
+          <p:cNvPr id="19" name="Rounded Rectangle 18"/>
+          <p:cNvSpPr/>
+          <p:nvPr/>
+        </p:nvSpPr>
+        <p:spPr>
+          <a:xfrm>
+            <a:off x="8906256" y="1828800"/>
+            <a:ext cx="2542032" cy="4343400"/>
+          </a:xfrm>
+          <a:prstGeom prst="roundRect">
+            <a:avLst/>
+          </a:prstGeom>
+          <a:solidFill>
+            <a:srgbClr val="FFFFFF"/>
+          </a:solidFill>
+          <a:ln w="12700">
+            <a:solidFill>
+              <a:srgbClr val="E2E8F0"/>
+            </a:solidFill>
+          </a:ln>
+        </p:spPr>
+        <p:style>
+          <a:lnRef idx="1">
+            <a:schemeClr val="accent1"/>
+          </a:lnRef>
+          <a:fillRef idx="3">
+            <a:schemeClr val="accent1"/>
+          </a:fillRef>
+          <a:effectRef idx="2">
+            <a:schemeClr val="accent1"/>
+          </a:effectRef>
+          <a:fontRef idx="minor">
+            <a:schemeClr val="lt1"/>
+          </a:fontRef>
+        </p:style>
+        <p:txBody>
+          <a:bodyPr rtlCol="0" anchor="ctr"/>
+          <a:lstStyle/>
+          <a:p>
+            <a:pPr algn="ctr"/>
+          </a:p>
+        </p:txBody>
+      </p:sp>
+      <p:sp>
+        <p:nvSpPr>
+          <p:cNvPr id="20" name="Rounded Rectangle 19"/>
+          <p:cNvSpPr/>
+          <p:nvPr/>
+        </p:nvSpPr>
+        <p:spPr>
+          <a:xfrm>
+            <a:off x="8906256" y="1828800"/>
+            <a:ext cx="2542032" cy="54864"/>
+          </a:xfrm>
+          <a:prstGeom prst="roundRect">
+            <a:avLst/>
+          </a:prstGeom>
+          <a:solidFill>
+            <a:srgbClr val="0284C7"/>
+          </a:solidFill>
+          <a:ln>
+            <a:noFill/>
+          </a:ln>
+        </p:spPr>
+        <p:style>
+          <a:lnRef idx="1">
+            <a:schemeClr val="accent1"/>
+          </a:lnRef>
+          <a:fillRef idx="3">
+            <a:schemeClr val="accent1"/>
+          </a:fillRef>
+          <a:effectRef idx="2">
+            <a:schemeClr val="accent1"/>
+          </a:effectRef>
+          <a:fontRef idx="minor">
+            <a:schemeClr val="lt1"/>
+          </a:fontRef>
+        </p:style>
+        <p:txBody>
+          <a:bodyPr rtlCol="0" anchor="ctr"/>
+          <a:lstStyle/>
+          <a:p>
+            <a:pPr algn="ctr"/>
+          </a:p>
+        </p:txBody>
+      </p:sp>
+      <p:sp>
+        <p:nvSpPr>
+          <p:cNvPr id="21" name="TextBox 20"/>
+          <p:cNvSpPr txBox="1"/>
+          <p:nvPr/>
+        </p:nvSpPr>
+        <p:spPr>
+          <a:xfrm>
+            <a:off x="9089136" y="1965960"/>
+            <a:ext cx="2176272" cy="4069080"/>
+          </a:xfrm>
+          <a:prstGeom prst="rect">
+            <a:avLst/>
+          </a:prstGeom>
+          <a:noFill/>
+        </p:spPr>
+        <p:txBody>
+          <a:bodyPr wrap="square">
+            <a:spAutoFit/>
+          </a:bodyPr>
+          <a:lstStyle/>
           <a:p>
             <a:pPr>
               <a:spcAft>
-                <a:spcPts val="400"/>
+                <a:spcPts val="800"/>
               </a:spcAft>
-              <a:defRPr sz="1000" b="1">
-                <a:solidFill>
-                  <a:srgbClr val="00E5FF"/>
+              <a:defRPr sz="950" b="1">
+                <a:solidFill>
+                  <a:srgbClr val="0284C7"/>
                 </a:solidFill>
                 <a:latin typeface="Consolas"/>
               </a:defRPr>
             </a:pPr>
             <a:r>
+              <a:t>04 / REFUND MISMATCHES</a:t>
+            </a:r>
+          </a:p>
+          <a:p>
+            <a:pPr>
+              <a:spcAft>
+                <a:spcPts val="1000"/>
+              </a:spcAft>
+              <a:defRPr sz="1600" b="1">
+                <a:solidFill>
+                  <a:srgbClr val="0F172A"/>
+                </a:solidFill>
+                <a:latin typeface="Segoe UI"/>
+              </a:defRPr>
+            </a:pPr>
+            <a:r>
+              <a:t>Pre-Auth Captures</a:t>
+            </a:r>
+          </a:p>
+          <a:p>
+            <a:pPr>
+              <a:spcAft>
+                <a:spcPts val="1400"/>
+              </a:spcAft>
+              <a:defRPr sz="1200">
+                <a:solidFill>
+                  <a:srgbClr val="475569"/>
+                </a:solidFill>
+                <a:latin typeface="Segoe UI"/>
+              </a:defRPr>
+            </a:pPr>
+            <a:r>
+              <a:t>Pre-auth transactions captured on hold but unreconciled against cancellations.</a:t>
+            </a:r>
+          </a:p>
+        </p:txBody>
+      </p:sp>
+      <p:sp>
+        <p:nvSpPr>
+          <p:cNvPr id="22" name="Rounded Rectangle 21"/>
+          <p:cNvSpPr/>
+          <p:nvPr/>
+        </p:nvSpPr>
+        <p:spPr>
+          <a:xfrm>
+            <a:off x="9043416" y="4754880"/>
+            <a:ext cx="2267712" cy="1188720"/>
+          </a:xfrm>
+          <a:prstGeom prst="roundRect">
+            <a:avLst/>
+          </a:prstGeom>
+          <a:solidFill>
+            <a:srgbClr val="E0F2FE"/>
+          </a:solidFill>
+          <a:ln w="6350">
+            <a:solidFill>
+              <a:srgbClr val="0284C7"/>
+            </a:solidFill>
+          </a:ln>
+        </p:spPr>
+        <p:style>
+          <a:lnRef idx="1">
+            <a:schemeClr val="accent1"/>
+          </a:lnRef>
+          <a:fillRef idx="3">
+            <a:schemeClr val="accent1"/>
+          </a:fillRef>
+          <a:effectRef idx="2">
+            <a:schemeClr val="accent1"/>
+          </a:effectRef>
+          <a:fontRef idx="minor">
+            <a:schemeClr val="lt1"/>
+          </a:fontRef>
+        </p:style>
+        <p:txBody>
+          <a:bodyPr rtlCol="0" anchor="ctr" wrap="square"/>
+          <a:lstStyle/>
+          <a:p>
+            <a:pPr algn="ctr">
+              <a:defRPr sz="1100" b="1">
+                <a:solidFill>
+                  <a:srgbClr val="0284C7"/>
+                </a:solidFill>
+                <a:latin typeface="Segoe UI"/>
+              </a:defRPr>
+            </a:pPr>
+            <a:r>
               <a:t>CORE RISK:</a:t>
             </a:r>
-          </a:p>
-          <a:p>
-            <a:pPr>
-              <a:defRPr sz="1150">
-                <a:solidFill>
-                  <a:srgbClr val="BAE6FD"/>
-                </a:solidFill>
-                <a:latin typeface="Segoe UI"/>
-              </a:defRPr>
-            </a:pPr>
-            <a:r>
-              <a:t>Unresolved holds tie up liquidity and trigger high dispute / chargeback operational fees.</a:t>
-            </a:r>
-          </a:p>
-        </p:txBody>
-      </p:sp>
-      <p:sp>
-        <p:nvSpPr>
-          <p:cNvPr id="19" name="TextBox 18"/>
+            <a:br/>
+            <a:r>
+              <a:t>Unresolved holds tie up merchant liquidity and create dispute exposure.</a:t>
+            </a:r>
+          </a:p>
+        </p:txBody>
+      </p:sp>
+      <p:sp>
+        <p:nvSpPr>
+          <p:cNvPr id="23" name="TextBox 22"/>
           <p:cNvSpPr txBox="1"/>
           <p:nvPr/>
         </p:nvSpPr>
@@ -5073,13 +5193,13 @@
             <a:pPr>
               <a:defRPr sz="900">
                 <a:solidFill>
-                  <a:srgbClr val="5A6E8C"/>
-                </a:solidFill>
-                <a:latin typeface="Consolas"/>
-              </a:defRPr>
-            </a:pPr>
-            <a:r>
-              <a:t>RecoverIQ  //  AI Revenue Recovery Opportunity Engine  |  Razorpay AI Buildathon (Track 3)  |  Slide 2 of 9</a:t>
+                  <a:srgbClr val="64748B"/>
+                </a:solidFill>
+                <a:latin typeface="Segoe UI"/>
+              </a:defRPr>
+            </a:pPr>
+            <a:r>
+              <a:t>RecoverIQ  |  AI Revenue Recovery Engine  |  Razorpay AI Buildathon  |  Slide 2 of 9</a:t>
             </a:r>
           </a:p>
         </p:txBody>
@@ -5117,7 +5237,7 @@
             <a:avLst/>
           </a:prstGeom>
           <a:solidFill>
-            <a:srgbClr val="080C16"/>
+            <a:srgbClr val="F8FAFC"/>
           </a:solidFill>
           <a:ln>
             <a:noFill/>
@@ -5154,13 +5274,13 @@
         <p:spPr>
           <a:xfrm>
             <a:off x="0" y="0"/>
-            <a:ext cx="12191695" cy="73152"/>
+            <a:ext cx="12191695" cy="54864"/>
           </a:xfrm>
           <a:prstGeom prst="rect">
             <a:avLst/>
           </a:prstGeom>
           <a:solidFill>
-            <a:srgbClr val="00E5FF"/>
+            <a:srgbClr val="0284C7"/>
           </a:solidFill>
           <a:ln>
             <a:noFill/>
@@ -5197,17 +5317,17 @@
         <p:spPr>
           <a:xfrm>
             <a:off x="731520" y="384048"/>
-            <a:ext cx="2322576" cy="292608"/>
+            <a:ext cx="1389888" cy="292608"/>
           </a:xfrm>
           <a:prstGeom prst="roundRect">
             <a:avLst/>
           </a:prstGeom>
           <a:solidFill>
-            <a:srgbClr val="102036"/>
+            <a:srgbClr val="E0F2FE"/>
           </a:solidFill>
           <a:ln w="12700">
             <a:solidFill>
-              <a:srgbClr val="00E5FF"/>
+              <a:srgbClr val="0284C7"/>
             </a:solidFill>
           </a:ln>
         </p:spPr>
@@ -5232,13 +5352,13 @@
             <a:pPr algn="ctr">
               <a:defRPr sz="950" b="1">
                 <a:solidFill>
-                  <a:srgbClr val="00E5FF"/>
+                  <a:srgbClr val="0284C7"/>
                 </a:solidFill>
                 <a:latin typeface="Consolas"/>
               </a:defRPr>
             </a:pPr>
             <a:r>
-              <a:t>AI RECOVERY ARCHITECTURE</a:t>
+              <a:t>THE SOLUTION</a:t>
             </a:r>
           </a:p>
         </p:txBody>
@@ -5268,13 +5388,13 @@
             <a:pPr>
               <a:defRPr sz="2300" b="1">
                 <a:solidFill>
-                  <a:srgbClr val="FFFFFF"/>
+                  <a:srgbClr val="0F172A"/>
                 </a:solidFill>
                 <a:latin typeface="Segoe UI"/>
               </a:defRPr>
             </a:pPr>
             <a:r>
-              <a:t>One engine that ranks opportunities, not just retries payments</a:t>
+              <a:t>Ranks opportunities, not just retries payments</a:t>
             </a:r>
           </a:p>
         </p:txBody>
@@ -5304,13 +5424,13 @@
             <a:pPr>
               <a:defRPr sz="1300">
                 <a:solidFill>
-                  <a:srgbClr val="94A3B8"/>
+                  <a:srgbClr val="475569"/>
                 </a:solidFill>
                 <a:latin typeface="Segoe UI"/>
               </a:defRPr>
             </a:pPr>
             <a:r>
-              <a:t>An intelligent closed-loop workflow that transforms noisy payment anomalies into maximized recovered revenue.</a:t>
+              <a:t>A closed-loop workflow that transforms noisy payment anomalies into prioritized, safe, and audited actions.</a:t>
             </a:r>
           </a:p>
         </p:txBody>
@@ -5330,11 +5450,11 @@
             <a:avLst/>
           </a:prstGeom>
           <a:solidFill>
-            <a:srgbClr val="10182A"/>
-          </a:solidFill>
-          <a:ln w="15240">
+            <a:srgbClr val="FFFFFF"/>
+          </a:solidFill>
+          <a:ln w="12700">
             <a:solidFill>
-              <a:srgbClr val="21304D"/>
+              <a:srgbClr val="E2E8F0"/>
             </a:solidFill>
           </a:ln>
         </p:spPr>
@@ -5375,7 +5495,7 @@
             <a:avLst/>
           </a:prstGeom>
           <a:solidFill>
-            <a:srgbClr val="00E5FF"/>
+            <a:srgbClr val="0284C7"/>
           </a:solidFill>
           <a:ln>
             <a:noFill/>
@@ -5431,7 +5551,7 @@
               </a:spcAft>
               <a:defRPr sz="950" b="1">
                 <a:solidFill>
-                  <a:srgbClr val="00E5FF"/>
+                  <a:srgbClr val="0284C7"/>
                 </a:solidFill>
                 <a:latin typeface="Consolas"/>
               </a:defRPr>
@@ -5447,7 +5567,7 @@
               </a:spcAft>
               <a:defRPr sz="2000" b="1">
                 <a:solidFill>
-                  <a:srgbClr val="FFFFFF"/>
+                  <a:srgbClr val="0F172A"/>
                 </a:solidFill>
                 <a:latin typeface="Segoe UI"/>
               </a:defRPr>
@@ -5463,26 +5583,26 @@
               </a:spcAft>
               <a:defRPr sz="1300" b="1">
                 <a:solidFill>
-                  <a:srgbClr val="00E5FF"/>
+                  <a:srgbClr val="0284C7"/>
                 </a:solidFill>
                 <a:latin typeface="Segoe UI"/>
               </a:defRPr>
             </a:pPr>
             <a:r>
-              <a:t>Multi-Vector Ingestion Engine</a:t>
+              <a:t>Multi-Vector Ingestion</a:t>
             </a:r>
           </a:p>
           <a:p>
             <a:pPr>
               <a:defRPr sz="1200">
                 <a:solidFill>
-                  <a:srgbClr val="94A3B8"/>
+                  <a:srgbClr val="475569"/>
                 </a:solidFill>
                 <a:latin typeface="Segoe UI"/>
               </a:defRPr>
             </a:pPr>
             <a:r>
-              <a:t>Continuously ingests events from Razorpay checkouts, partial payment agreements, B2B invoices, and pre-authorization queues. Normalizes heterogeneous payment records into unified recovery objects.</a:t>
+              <a:t>Continuously ingests events from Razorpay checkouts, partial agreements, B2B invoices, and pre-auth holds. Normalizes records into unified objects.</a:t>
             </a:r>
           </a:p>
         </p:txBody>
@@ -5502,11 +5622,11 @@
             <a:avLst/>
           </a:prstGeom>
           <a:solidFill>
-            <a:srgbClr val="10182A"/>
-          </a:solidFill>
-          <a:ln w="15240">
+            <a:srgbClr val="FFFFFF"/>
+          </a:solidFill>
+          <a:ln w="12700">
             <a:solidFill>
-              <a:srgbClr val="21304D"/>
+              <a:srgbClr val="E2E8F0"/>
             </a:solidFill>
           </a:ln>
         </p:spPr>
@@ -5547,7 +5667,7 @@
             <a:avLst/>
           </a:prstGeom>
           <a:solidFill>
-            <a:srgbClr val="6366F1"/>
+            <a:srgbClr val="0F172A"/>
           </a:solidFill>
           <a:ln>
             <a:noFill/>
@@ -5603,7 +5723,7 @@
               </a:spcAft>
               <a:defRPr sz="950" b="1">
                 <a:solidFill>
-                  <a:srgbClr val="6366F1"/>
+                  <a:srgbClr val="0F172A"/>
                 </a:solidFill>
                 <a:latin typeface="Consolas"/>
               </a:defRPr>
@@ -5619,7 +5739,7 @@
               </a:spcAft>
               <a:defRPr sz="2000" b="1">
                 <a:solidFill>
-                  <a:srgbClr val="FFFFFF"/>
+                  <a:srgbClr val="0F172A"/>
                 </a:solidFill>
                 <a:latin typeface="Segoe UI"/>
               </a:defRPr>
@@ -5635,7 +5755,7 @@
               </a:spcAft>
               <a:defRPr sz="1300" b="1">
                 <a:solidFill>
-                  <a:srgbClr val="6366F1"/>
+                  <a:srgbClr val="0F172A"/>
                 </a:solidFill>
                 <a:latin typeface="Segoe UI"/>
               </a:defRPr>
@@ -5648,13 +5768,13 @@
             <a:pPr>
               <a:defRPr sz="1200">
                 <a:solidFill>
-                  <a:srgbClr val="94A3B8"/>
+                  <a:srgbClr val="475569"/>
                 </a:solidFill>
                 <a:latin typeface="Segoe UI"/>
               </a:defRPr>
             </a:pPr>
             <a:r>
-              <a:t>Gradient Boosted Decision Trees trained on real behavioral features: delinquency age, customer tenure, historical late payment frequency, issuer switch performance, and transaction ticket size.</a:t>
+              <a:t>Gradient Boosted Decision Trees trained on real behavioral features: delinquency age, tenure, historical late frequency, switch performance, and ticket size.</a:t>
             </a:r>
           </a:p>
         </p:txBody>
@@ -5674,11 +5794,11 @@
             <a:avLst/>
           </a:prstGeom>
           <a:solidFill>
-            <a:srgbClr val="10182A"/>
-          </a:solidFill>
-          <a:ln w="15240">
+            <a:srgbClr val="FFFFFF"/>
+          </a:solidFill>
+          <a:ln w="12700">
             <a:solidFill>
-              <a:srgbClr val="21304D"/>
+              <a:srgbClr val="E2E8F0"/>
             </a:solidFill>
           </a:ln>
         </p:spPr>
@@ -5719,7 +5839,7 @@
             <a:avLst/>
           </a:prstGeom>
           <a:solidFill>
-            <a:srgbClr val="3395FF"/>
+            <a:srgbClr val="0066FF"/>
           </a:solidFill>
           <a:ln>
             <a:noFill/>
@@ -5775,7 +5895,7 @@
               </a:spcAft>
               <a:defRPr sz="950" b="1">
                 <a:solidFill>
-                  <a:srgbClr val="3395FF"/>
+                  <a:srgbClr val="0066FF"/>
                 </a:solidFill>
                 <a:latin typeface="Consolas"/>
               </a:defRPr>
@@ -5791,7 +5911,7 @@
               </a:spcAft>
               <a:defRPr sz="2000" b="1">
                 <a:solidFill>
-                  <a:srgbClr val="FFFFFF"/>
+                  <a:srgbClr val="0F172A"/>
                 </a:solidFill>
                 <a:latin typeface="Segoe UI"/>
               </a:defRPr>
@@ -5807,7 +5927,7 @@
               </a:spcAft>
               <a:defRPr sz="1300" b="1">
                 <a:solidFill>
-                  <a:srgbClr val="3395FF"/>
+                  <a:srgbClr val="0066FF"/>
                 </a:solidFill>
                 <a:latin typeface="Segoe UI"/>
               </a:defRPr>
@@ -5820,13 +5940,13 @@
             <a:pPr>
               <a:defRPr sz="1200">
                 <a:solidFill>
-                  <a:srgbClr val="94A3B8"/>
+                  <a:srgbClr val="475569"/>
                 </a:solidFill>
                 <a:latin typeface="Segoe UI"/>
               </a:defRPr>
             </a:pPr>
             <a:r>
-              <a:t>Formulates daily dunning as a bounded capacity optimization problem. Solves exact Dynamic Programming to maximize expected value under merchant outreach budget constraints.</a:t>
+              <a:t>Formulates daily dunning as a bounded capacity optimization problem. Solves exact Dynamic Programming to maximize expected value under constraints.</a:t>
             </a:r>
           </a:p>
         </p:txBody>
@@ -5846,11 +5966,11 @@
             <a:avLst/>
           </a:prstGeom>
           <a:solidFill>
-            <a:srgbClr val="10182A"/>
-          </a:solidFill>
-          <a:ln w="15240">
+            <a:srgbClr val="FFFFFF"/>
+          </a:solidFill>
+          <a:ln w="12700">
             <a:solidFill>
-              <a:srgbClr val="21304D"/>
+              <a:srgbClr val="E2E8F0"/>
             </a:solidFill>
           </a:ln>
         </p:spPr>
@@ -5891,7 +6011,7 @@
             <a:avLst/>
           </a:prstGeom>
           <a:solidFill>
-            <a:srgbClr val="10B981"/>
+            <a:srgbClr val="059669"/>
           </a:solidFill>
           <a:ln>
             <a:noFill/>
@@ -5947,7 +6067,7 @@
               </a:spcAft>
               <a:defRPr sz="950" b="1">
                 <a:solidFill>
-                  <a:srgbClr val="10B981"/>
+                  <a:srgbClr val="059669"/>
                 </a:solidFill>
                 <a:latin typeface="Consolas"/>
               </a:defRPr>
@@ -5963,7 +6083,7 @@
               </a:spcAft>
               <a:defRPr sz="2000" b="1">
                 <a:solidFill>
-                  <a:srgbClr val="FFFFFF"/>
+                  <a:srgbClr val="0F172A"/>
                 </a:solidFill>
                 <a:latin typeface="Segoe UI"/>
               </a:defRPr>
@@ -5979,7 +6099,7 @@
               </a:spcAft>
               <a:defRPr sz="1300" b="1">
                 <a:solidFill>
-                  <a:srgbClr val="10B981"/>
+                  <a:srgbClr val="059669"/>
                 </a:solidFill>
                 <a:latin typeface="Segoe UI"/>
               </a:defRPr>
@@ -5992,13 +6112,13 @@
             <a:pPr>
               <a:defRPr sz="1200">
                 <a:solidFill>
-                  <a:srgbClr val="94A3B8"/>
+                  <a:srgbClr val="475569"/>
                 </a:solidFill>
                 <a:latin typeface="Segoe UI"/>
               </a:defRPr>
             </a:pPr>
             <a:r>
-              <a:t>Deterministic guardrails enforce spend ceilings, issuer switch health, and dunning frequency backoffs before 1-click execution. Quarantines unverified accounts to human review.</a:t>
+              <a:t>Deterministic guardrails enforce spend ceilings, switch health, and frequency backoffs before 1-click execution. Quarantines unverified accounts.</a:t>
             </a:r>
           </a:p>
         </p:txBody>
@@ -6028,13 +6148,13 @@
             <a:pPr>
               <a:defRPr sz="900">
                 <a:solidFill>
-                  <a:srgbClr val="5A6E8C"/>
-                </a:solidFill>
-                <a:latin typeface="Consolas"/>
-              </a:defRPr>
-            </a:pPr>
-            <a:r>
-              <a:t>RecoverIQ  //  AI Revenue Recovery Opportunity Engine  |  Razorpay AI Buildathon (Track 3)  |  Slide 3 of 9</a:t>
+                  <a:srgbClr val="64748B"/>
+                </a:solidFill>
+                <a:latin typeface="Segoe UI"/>
+              </a:defRPr>
+            </a:pPr>
+            <a:r>
+              <a:t>RecoverIQ  |  AI Revenue Recovery Engine  |  Razorpay AI Buildathon  |  Slide 3 of 9</a:t>
             </a:r>
           </a:p>
         </p:txBody>
@@ -6072,7 +6192,7 @@
             <a:avLst/>
           </a:prstGeom>
           <a:solidFill>
-            <a:srgbClr val="080C16"/>
+            <a:srgbClr val="F8FAFC"/>
           </a:solidFill>
           <a:ln>
             <a:noFill/>
@@ -6109,13 +6229,13 @@
         <p:spPr>
           <a:xfrm>
             <a:off x="0" y="0"/>
-            <a:ext cx="12191695" cy="73152"/>
+            <a:ext cx="12191695" cy="54864"/>
           </a:xfrm>
           <a:prstGeom prst="rect">
             <a:avLst/>
           </a:prstGeom>
           <a:solidFill>
-            <a:srgbClr val="00E5FF"/>
+            <a:srgbClr val="0284C7"/>
           </a:solidFill>
           <a:ln>
             <a:noFill/>
@@ -6152,17 +6272,17 @@
         <p:spPr>
           <a:xfrm>
             <a:off x="731520" y="384048"/>
-            <a:ext cx="2478024" cy="292608"/>
+            <a:ext cx="1389888" cy="292608"/>
           </a:xfrm>
           <a:prstGeom prst="roundRect">
             <a:avLst/>
           </a:prstGeom>
           <a:solidFill>
-            <a:srgbClr val="102036"/>
+            <a:srgbClr val="E0F2FE"/>
           </a:solidFill>
           <a:ln w="12700">
             <a:solidFill>
-              <a:srgbClr val="00E5FF"/>
+              <a:srgbClr val="0284C7"/>
             </a:solidFill>
           </a:ln>
         </p:spPr>
@@ -6187,13 +6307,13 @@
             <a:pPr algn="ctr">
               <a:defRPr sz="950" b="1">
                 <a:solidFill>
-                  <a:srgbClr val="00E5FF"/>
+                  <a:srgbClr val="0284C7"/>
                 </a:solidFill>
                 <a:latin typeface="Consolas"/>
               </a:defRPr>
             </a:pPr>
             <a:r>
-              <a:t>END-TO-END SYSTEM PIPELINE</a:t>
+              <a:t>ARCHITECTURE</a:t>
             </a:r>
           </a:p>
         </p:txBody>
@@ -6223,13 +6343,13 @@
             <a:pPr>
               <a:defRPr sz="2300" b="1">
                 <a:solidFill>
-                  <a:srgbClr val="FFFFFF"/>
+                  <a:srgbClr val="0F172A"/>
                 </a:solidFill>
                 <a:latin typeface="Segoe UI"/>
               </a:defRPr>
             </a:pPr>
             <a:r>
-              <a:t>From a raw event to a verified, audited outcome</a:t>
+              <a:t>From a raw event to a verified outcome</a:t>
             </a:r>
           </a:p>
         </p:txBody>
@@ -6259,7 +6379,7 @@
             <a:pPr>
               <a:defRPr sz="1300">
                 <a:solidFill>
-                  <a:srgbClr val="94A3B8"/>
+                  <a:srgbClr val="475569"/>
                 </a:solidFill>
                 <a:latin typeface="Segoe UI"/>
               </a:defRPr>
@@ -6285,11 +6405,11 @@
             <a:avLst/>
           </a:prstGeom>
           <a:solidFill>
-            <a:srgbClr val="0C121E"/>
+            <a:srgbClr val="F1F5F9"/>
           </a:solidFill>
           <a:ln w="12700">
             <a:solidFill>
-              <a:srgbClr val="283855"/>
+              <a:srgbClr val="E2E8F0"/>
             </a:solidFill>
           </a:ln>
         </p:spPr>
@@ -6314,7 +6434,7 @@
             <a:pPr algn="ctr">
               <a:defRPr sz="850" b="1">
                 <a:solidFill>
-                  <a:srgbClr val="283855"/>
+                  <a:srgbClr val="64748B"/>
                 </a:solidFill>
                 <a:latin typeface="Consolas"/>
               </a:defRPr>
@@ -6327,13 +6447,13 @@
             <a:pPr algn="ctr">
               <a:defRPr sz="1050" b="1">
                 <a:solidFill>
-                  <a:srgbClr val="FFFFFF"/>
+                  <a:srgbClr val="0F172A"/>
                 </a:solidFill>
                 <a:latin typeface="Segoe UI"/>
               </a:defRPr>
             </a:pPr>
             <a:r>
-              <a:t>Raw Event Ingestion</a:t>
+              <a:t>Raw Event Ingest</a:t>
             </a:r>
           </a:p>
         </p:txBody>
@@ -6353,11 +6473,11 @@
             <a:avLst/>
           </a:prstGeom>
           <a:solidFill>
-            <a:srgbClr val="0C121E"/>
+            <a:srgbClr val="F1F5F9"/>
           </a:solidFill>
           <a:ln w="12700">
             <a:solidFill>
-              <a:srgbClr val="283855"/>
+              <a:srgbClr val="E2E8F0"/>
             </a:solidFill>
           </a:ln>
         </p:spPr>
@@ -6382,7 +6502,7 @@
             <a:pPr algn="ctr">
               <a:defRPr sz="850" b="1">
                 <a:solidFill>
-                  <a:srgbClr val="283855"/>
+                  <a:srgbClr val="64748B"/>
                 </a:solidFill>
                 <a:latin typeface="Consolas"/>
               </a:defRPr>
@@ -6395,13 +6515,13 @@
             <a:pPr algn="ctr">
               <a:defRPr sz="1050" b="1">
                 <a:solidFill>
-                  <a:srgbClr val="FFFFFF"/>
+                  <a:srgbClr val="0F172A"/>
                 </a:solidFill>
                 <a:latin typeface="Segoe UI"/>
               </a:defRPr>
             </a:pPr>
             <a:r>
-              <a:t>Vector Detector</a:t>
+              <a:t>Vector Detect</a:t>
             </a:r>
           </a:p>
         </p:txBody>
@@ -6421,11 +6541,11 @@
             <a:avLst/>
           </a:prstGeom>
           <a:solidFill>
-            <a:srgbClr val="142036"/>
+            <a:srgbClr val="F0F9FF"/>
           </a:solidFill>
           <a:ln w="19050">
             <a:solidFill>
-              <a:srgbClr val="00E5FF"/>
+              <a:srgbClr val="0284C7"/>
             </a:solidFill>
           </a:ln>
         </p:spPr>
@@ -6450,7 +6570,7 @@
             <a:pPr algn="ctr">
               <a:defRPr sz="850" b="1">
                 <a:solidFill>
-                  <a:srgbClr val="00E5FF"/>
+                  <a:srgbClr val="0284C7"/>
                 </a:solidFill>
                 <a:latin typeface="Consolas"/>
               </a:defRPr>
@@ -6463,13 +6583,13 @@
             <a:pPr algn="ctr">
               <a:defRPr sz="1050" b="1">
                 <a:solidFill>
-                  <a:srgbClr val="FFFFFF"/>
+                  <a:srgbClr val="0F172A"/>
                 </a:solidFill>
                 <a:latin typeface="Segoe UI"/>
               </a:defRPr>
             </a:pPr>
             <a:r>
-              <a:t>GBDT Predictor</a:t>
+              <a:t>GBDT Predict</a:t>
             </a:r>
           </a:p>
         </p:txBody>
@@ -6489,11 +6609,11 @@
             <a:avLst/>
           </a:prstGeom>
           <a:solidFill>
-            <a:srgbClr val="0C121E"/>
+            <a:srgbClr val="F1F5F9"/>
           </a:solidFill>
           <a:ln w="12700">
             <a:solidFill>
-              <a:srgbClr val="283855"/>
+              <a:srgbClr val="E2E8F0"/>
             </a:solidFill>
           </a:ln>
         </p:spPr>
@@ -6518,7 +6638,7 @@
             <a:pPr algn="ctr">
               <a:defRPr sz="850" b="1">
                 <a:solidFill>
-                  <a:srgbClr val="283855"/>
+                  <a:srgbClr val="64748B"/>
                 </a:solidFill>
                 <a:latin typeface="Consolas"/>
               </a:defRPr>
@@ -6531,13 +6651,13 @@
             <a:pPr algn="ctr">
               <a:defRPr sz="1050" b="1">
                 <a:solidFill>
-                  <a:srgbClr val="FFFFFF"/>
+                  <a:srgbClr val="0F172A"/>
                 </a:solidFill>
                 <a:latin typeface="Segoe UI"/>
               </a:defRPr>
             </a:pPr>
             <a:r>
-              <a:t>Expected Value Scorer</a:t>
+              <a:t>Expected Value</a:t>
             </a:r>
           </a:p>
         </p:txBody>
@@ -6557,11 +6677,11 @@
             <a:avLst/>
           </a:prstGeom>
           <a:solidFill>
-            <a:srgbClr val="142036"/>
+            <a:srgbClr val="F0F9FF"/>
           </a:solidFill>
           <a:ln w="19050">
             <a:solidFill>
-              <a:srgbClr val="00E5FF"/>
+              <a:srgbClr val="0284C7"/>
             </a:solidFill>
           </a:ln>
         </p:spPr>
@@ -6586,7 +6706,7 @@
             <a:pPr algn="ctr">
               <a:defRPr sz="850" b="1">
                 <a:solidFill>
-                  <a:srgbClr val="00E5FF"/>
+                  <a:srgbClr val="0284C7"/>
                 </a:solidFill>
                 <a:latin typeface="Consolas"/>
               </a:defRPr>
@@ -6599,7 +6719,7 @@
             <a:pPr algn="ctr">
               <a:defRPr sz="1050" b="1">
                 <a:solidFill>
-                  <a:srgbClr val="FFFFFF"/>
+                  <a:srgbClr val="0F172A"/>
                 </a:solidFill>
                 <a:latin typeface="Segoe UI"/>
               </a:defRPr>
@@ -6625,11 +6745,11 @@
             <a:avLst/>
           </a:prstGeom>
           <a:solidFill>
-            <a:srgbClr val="142036"/>
+            <a:srgbClr val="F0F9FF"/>
           </a:solidFill>
           <a:ln w="19050">
             <a:solidFill>
-              <a:srgbClr val="00E5FF"/>
+              <a:srgbClr val="0284C7"/>
             </a:solidFill>
           </a:ln>
         </p:spPr>
@@ -6654,7 +6774,7 @@
             <a:pPr algn="ctr">
               <a:defRPr sz="850" b="1">
                 <a:solidFill>
-                  <a:srgbClr val="00E5FF"/>
+                  <a:srgbClr val="0284C7"/>
                 </a:solidFill>
                 <a:latin typeface="Consolas"/>
               </a:defRPr>
@@ -6667,7 +6787,7 @@
             <a:pPr algn="ctr">
               <a:defRPr sz="1050" b="1">
                 <a:solidFill>
-                  <a:srgbClr val="FFFFFF"/>
+                  <a:srgbClr val="0F172A"/>
                 </a:solidFill>
                 <a:latin typeface="Segoe UI"/>
               </a:defRPr>
@@ -6693,11 +6813,11 @@
             <a:avLst/>
           </a:prstGeom>
           <a:solidFill>
-            <a:srgbClr val="142036"/>
+            <a:srgbClr val="F0F9FF"/>
           </a:solidFill>
           <a:ln w="19050">
             <a:solidFill>
-              <a:srgbClr val="00E5FF"/>
+              <a:srgbClr val="0284C7"/>
             </a:solidFill>
           </a:ln>
         </p:spPr>
@@ -6722,7 +6842,7 @@
             <a:pPr algn="ctr">
               <a:defRPr sz="850" b="1">
                 <a:solidFill>
-                  <a:srgbClr val="00E5FF"/>
+                  <a:srgbClr val="0284C7"/>
                 </a:solidFill>
                 <a:latin typeface="Consolas"/>
               </a:defRPr>
@@ -6735,7 +6855,7 @@
             <a:pPr algn="ctr">
               <a:defRPr sz="1050" b="1">
                 <a:solidFill>
-                  <a:srgbClr val="FFFFFF"/>
+                  <a:srgbClr val="0F172A"/>
                 </a:solidFill>
                 <a:latin typeface="Segoe UI"/>
               </a:defRPr>
@@ -6761,11 +6881,11 @@
             <a:avLst/>
           </a:prstGeom>
           <a:solidFill>
-            <a:srgbClr val="0C121E"/>
+            <a:srgbClr val="F1F5F9"/>
           </a:solidFill>
           <a:ln w="12700">
             <a:solidFill>
-              <a:srgbClr val="283855"/>
+              <a:srgbClr val="E2E8F0"/>
             </a:solidFill>
           </a:ln>
         </p:spPr>
@@ -6790,7 +6910,7 @@
             <a:pPr algn="ctr">
               <a:defRPr sz="850" b="1">
                 <a:solidFill>
-                  <a:srgbClr val="283855"/>
+                  <a:srgbClr val="64748B"/>
                 </a:solidFill>
                 <a:latin typeface="Consolas"/>
               </a:defRPr>
@@ -6803,13 +6923,13 @@
             <a:pPr algn="ctr">
               <a:defRPr sz="1050" b="1">
                 <a:solidFill>
-                  <a:srgbClr val="FFFFFF"/>
+                  <a:srgbClr val="0F172A"/>
                 </a:solidFill>
                 <a:latin typeface="Segoe UI"/>
               </a:defRPr>
             </a:pPr>
             <a:r>
-              <a:t>Audit &amp; Cloud Sync</a:t>
+              <a:t>Audit &amp; Sync</a:t>
             </a:r>
           </a:p>
         </p:txBody>
@@ -6829,11 +6949,11 @@
             <a:avLst/>
           </a:prstGeom>
           <a:solidFill>
-            <a:srgbClr val="10182A"/>
-          </a:solidFill>
-          <a:ln w="15240">
+            <a:srgbClr val="FFFFFF"/>
+          </a:solidFill>
+          <a:ln w="12700">
             <a:solidFill>
-              <a:srgbClr val="21304D"/>
+              <a:srgbClr val="E2E8F0"/>
             </a:solidFill>
           </a:ln>
         </p:spPr>
@@ -6874,7 +6994,7 @@
             <a:avLst/>
           </a:prstGeom>
           <a:solidFill>
-            <a:srgbClr val="10B981"/>
+            <a:srgbClr val="059669"/>
           </a:solidFill>
           <a:ln>
             <a:noFill/>
@@ -6930,7 +7050,7 @@
               </a:spcAft>
               <a:defRPr sz="1100" b="1">
                 <a:solidFill>
-                  <a:srgbClr val="10B981"/>
+                  <a:srgbClr val="059669"/>
                 </a:solidFill>
                 <a:latin typeface="Consolas"/>
               </a:defRPr>
@@ -6946,7 +7066,7 @@
               </a:spcAft>
               <a:defRPr sz="1500" b="1">
                 <a:solidFill>
-                  <a:srgbClr val="FFFFFF"/>
+                  <a:srgbClr val="0F172A"/>
                 </a:solidFill>
                 <a:latin typeface="Segoe UI"/>
               </a:defRPr>
@@ -6962,13 +7082,13 @@
               </a:spcAft>
               <a:defRPr sz="1100">
                 <a:solidFill>
-                  <a:srgbClr val="94A3B8"/>
+                  <a:srgbClr val="475569"/>
                 </a:solidFill>
                 <a:latin typeface="Segoe UI"/>
               </a:defRPr>
             </a:pPr>
             <a:r>
-              <a:t>[OK]  Isolation of AI Inference: ML models output probability vectors; hard-coded rules decide actionability.</a:t>
+              <a:t>•  Isolation of AI Inference: ML outputs probability; hard-coded rules decide action.</a:t>
             </a:r>
           </a:p>
           <a:p>
@@ -6978,13 +7098,13 @@
               </a:spcAft>
               <a:defRPr sz="1100">
                 <a:solidFill>
-                  <a:srgbClr val="94A3B8"/>
+                  <a:srgbClr val="475569"/>
                 </a:solidFill>
                 <a:latin typeface="Segoe UI"/>
               </a:defRPr>
             </a:pPr>
             <a:r>
-              <a:t>[OK]  Deterministic Guardrail Firewall: Evaluates spend thresholds, transaction frequency caps, and switch latency.</a:t>
+              <a:t>•  Deterministic Firewall: Evaluates spend thresholds, frequency caps, and switch latency.</a:t>
             </a:r>
           </a:p>
           <a:p>
@@ -6994,13 +7114,13 @@
               </a:spcAft>
               <a:defRPr sz="1100">
                 <a:solidFill>
-                  <a:srgbClr val="94A3B8"/>
+                  <a:srgbClr val="475569"/>
                 </a:solidFill>
                 <a:latin typeface="Segoe UI"/>
               </a:defRPr>
             </a:pPr>
             <a:r>
-              <a:t>[OK]  Auto-Quarantine Routing: High-value anomalies (&gt;Rs 10,000) with confidence &lt; 70% are diverted to human review.</a:t>
+              <a:t>•  Auto-Quarantine Routing: High-value anomalies (&gt;Rs 10,000) with confidence &lt; 70% divert to human review.</a:t>
             </a:r>
           </a:p>
           <a:p>
@@ -7010,13 +7130,13 @@
               </a:spcAft>
               <a:defRPr sz="1100">
                 <a:solidFill>
-                  <a:srgbClr val="94A3B8"/>
+                  <a:srgbClr val="475569"/>
                 </a:solidFill>
                 <a:latin typeface="Segoe UI"/>
               </a:defRPr>
             </a:pPr>
             <a:r>
-              <a:t>[OK]  Zero Hallucination Risk: Mathematical bounds guarantee no fabricated recovery actions or unauthorized retries.</a:t>
+              <a:t>•  Zero Hallucination: Mathematical bounds guarantee no fabricated recovery actions.</a:t>
             </a:r>
           </a:p>
         </p:txBody>
@@ -7036,11 +7156,11 @@
             <a:avLst/>
           </a:prstGeom>
           <a:solidFill>
-            <a:srgbClr val="10182A"/>
-          </a:solidFill>
-          <a:ln w="15240">
+            <a:srgbClr val="FFFFFF"/>
+          </a:solidFill>
+          <a:ln w="12700">
             <a:solidFill>
-              <a:srgbClr val="21304D"/>
+              <a:srgbClr val="E2E8F0"/>
             </a:solidFill>
           </a:ln>
         </p:spPr>
@@ -7081,7 +7201,7 @@
             <a:avLst/>
           </a:prstGeom>
           <a:solidFill>
-            <a:srgbClr val="3395FF"/>
+            <a:srgbClr val="0066FF"/>
           </a:solidFill>
           <a:ln>
             <a:noFill/>
@@ -7137,7 +7257,7 @@
               </a:spcAft>
               <a:defRPr sz="1100" b="1">
                 <a:solidFill>
-                  <a:srgbClr val="3395FF"/>
+                  <a:srgbClr val="0066FF"/>
                 </a:solidFill>
                 <a:latin typeface="Consolas"/>
               </a:defRPr>
@@ -7153,7 +7273,7 @@
               </a:spcAft>
               <a:defRPr sz="1500" b="1">
                 <a:solidFill>
-                  <a:srgbClr val="FFFFFF"/>
+                  <a:srgbClr val="0F172A"/>
                 </a:solidFill>
                 <a:latin typeface="Segoe UI"/>
               </a:defRPr>
@@ -7169,13 +7289,13 @@
               </a:spcAft>
               <a:defRPr sz="1100">
                 <a:solidFill>
-                  <a:srgbClr val="94A3B8"/>
+                  <a:srgbClr val="475569"/>
                 </a:solidFill>
                 <a:latin typeface="Segoe UI"/>
               </a:defRPr>
             </a:pPr>
             <a:r>
-              <a:t>[&gt;&gt;]  FastAPI Asynchronous Engine: Sub-18ms REST latency with pooled SQLite/SQLAlchemy connections.</a:t>
+              <a:t>•  FastAPI Asynchronous Engine: Sub-18ms REST latency with pooled SQLite connections.</a:t>
             </a:r>
           </a:p>
           <a:p>
@@ -7185,13 +7305,13 @@
               </a:spcAft>
               <a:defRPr sz="1100">
                 <a:solidFill>
-                  <a:srgbClr val="94A3B8"/>
+                  <a:srgbClr val="475569"/>
                 </a:solidFill>
                 <a:latin typeface="Segoe UI"/>
               </a:defRPr>
             </a:pPr>
             <a:r>
-              <a:t>[&gt;&gt;]  Razorpay SDK &amp; Webhooks: Direct payment link creation, smart switch retries, and HMAC-SHA256 signature verification.</a:t>
+              <a:t>•  Razorpay SDK &amp; Webhooks: Direct payment links, smart retries, and HMAC-SHA256.</a:t>
             </a:r>
           </a:p>
           <a:p>
@@ -7201,13 +7321,13 @@
               </a:spcAft>
               <a:defRPr sz="1100">
                 <a:solidFill>
-                  <a:srgbClr val="94A3B8"/>
+                  <a:srgbClr val="475569"/>
                 </a:solidFill>
                 <a:latin typeface="Segoe UI"/>
               </a:defRPr>
             </a:pPr>
             <a:r>
-              <a:t>[&gt;&gt;]  Real-Time Cloud Auto-Sync: Reconciles live payment status directly from Razorpay Cloud without ngrok tunnels.</a:t>
+              <a:t>•  Real-Time Cloud Auto-Sync: Reconciles live payment status directly from Razorpay Cloud.</a:t>
             </a:r>
           </a:p>
           <a:p>
@@ -7217,13 +7337,13 @@
               </a:spcAft>
               <a:defRPr sz="1100">
                 <a:solidFill>
-                  <a:srgbClr val="94A3B8"/>
+                  <a:srgbClr val="475569"/>
                 </a:solidFill>
                 <a:latin typeface="Segoe UI"/>
               </a:defRPr>
             </a:pPr>
             <a:r>
-              <a:t>[&gt;&gt;]  Immutable Audit Ledger: Every recovery outcome, parameter weight, and model score cryptographically stamped.</a:t>
+              <a:t>•  Immutable Audit Ledger: Every recovery outcome and model score cryptographically stamped.</a:t>
             </a:r>
           </a:p>
         </p:txBody>
@@ -7253,13 +7373,13 @@
             <a:pPr>
               <a:defRPr sz="900">
                 <a:solidFill>
-                  <a:srgbClr val="5A6E8C"/>
-                </a:solidFill>
-                <a:latin typeface="Consolas"/>
-              </a:defRPr>
-            </a:pPr>
-            <a:r>
-              <a:t>RecoverIQ  //  AI Revenue Recovery Opportunity Engine  |  Razorpay AI Buildathon (Track 3)  |  Slide 4 of 9</a:t>
+                  <a:srgbClr val="64748B"/>
+                </a:solidFill>
+                <a:latin typeface="Segoe UI"/>
+              </a:defRPr>
+            </a:pPr>
+            <a:r>
+              <a:t>RecoverIQ  |  AI Revenue Recovery Engine  |  Razorpay AI Buildathon  |  Slide 4 of 9</a:t>
             </a:r>
           </a:p>
         </p:txBody>
@@ -7297,7 +7417,7 @@
             <a:avLst/>
           </a:prstGeom>
           <a:solidFill>
-            <a:srgbClr val="080C16"/>
+            <a:srgbClr val="F8FAFC"/>
           </a:solidFill>
           <a:ln>
             <a:noFill/>
@@ -7334,13 +7454,13 @@
         <p:spPr>
           <a:xfrm>
             <a:off x="0" y="0"/>
-            <a:ext cx="12191695" cy="73152"/>
+            <a:ext cx="12191695" cy="54864"/>
           </a:xfrm>
           <a:prstGeom prst="rect">
             <a:avLst/>
           </a:prstGeom>
           <a:solidFill>
-            <a:srgbClr val="00E5FF"/>
+            <a:srgbClr val="0284C7"/>
           </a:solidFill>
           <a:ln>
             <a:noFill/>
@@ -7377,17 +7497,17 @@
         <p:spPr>
           <a:xfrm>
             <a:off x="731520" y="384048"/>
-            <a:ext cx="2400300" cy="292608"/>
+            <a:ext cx="1856232" cy="292608"/>
           </a:xfrm>
           <a:prstGeom prst="roundRect">
             <a:avLst/>
           </a:prstGeom>
           <a:solidFill>
-            <a:srgbClr val="102036"/>
+            <a:srgbClr val="E0F2FE"/>
           </a:solidFill>
           <a:ln w="12700">
             <a:solidFill>
-              <a:srgbClr val="00E5FF"/>
+              <a:srgbClr val="0284C7"/>
             </a:solidFill>
           </a:ln>
         </p:spPr>
@@ -7412,13 +7532,13 @@
             <a:pPr algn="ctr">
               <a:defRPr sz="950" b="1">
                 <a:solidFill>
-                  <a:srgbClr val="00E5FF"/>
+                  <a:srgbClr val="0284C7"/>
                 </a:solidFill>
                 <a:latin typeface="Consolas"/>
               </a:defRPr>
             </a:pPr>
             <a:r>
-              <a:t>MATHEMATICAL OPTIMIZATION</a:t>
+              <a:t>THE DIFFERENTIATOR</a:t>
             </a:r>
           </a:p>
         </p:txBody>
@@ -7448,13 +7568,13 @@
             <a:pPr>
               <a:defRPr sz="2300" b="1">
                 <a:solidFill>
-                  <a:srgbClr val="FFFFFF"/>
+                  <a:srgbClr val="0F172A"/>
                 </a:solidFill>
                 <a:latin typeface="Segoe UI"/>
               </a:defRPr>
             </a:pPr>
             <a:r>
-              <a:t>Not a sorted list — a solved allocation problem</a:t>
+              <a:t>A solved mathematical allocation problem</a:t>
             </a:r>
           </a:p>
         </p:txBody>
@@ -7484,13 +7604,13 @@
             <a:pPr>
               <a:defRPr sz="1300">
                 <a:solidFill>
-                  <a:srgbClr val="94A3B8"/>
+                  <a:srgbClr val="475569"/>
                 </a:solidFill>
                 <a:latin typeface="Segoe UI"/>
               </a:defRPr>
             </a:pPr>
             <a:r>
-              <a:t>Greedy FIFO sorting exhausts operational capacity on low-probability high-effort cases. RecoverIQ solves 0/1 Knapsack DP.</a:t>
+              <a:t>Greedy FIFO sorting exhausts operational capacity on low-probability cases. RecoverIQ solves 0/1 Knapsack DP.</a:t>
             </a:r>
           </a:p>
         </p:txBody>
@@ -7510,11 +7630,11 @@
             <a:avLst/>
           </a:prstGeom>
           <a:solidFill>
-            <a:srgbClr val="10182A"/>
-          </a:solidFill>
-          <a:ln w="15240">
+            <a:srgbClr val="FFFFFF"/>
+          </a:solidFill>
+          <a:ln w="12700">
             <a:solidFill>
-              <a:srgbClr val="21304D"/>
+              <a:srgbClr val="E2E8F0"/>
             </a:solidFill>
           </a:ln>
         </p:spPr>
@@ -7555,7 +7675,7 @@
             <a:avLst/>
           </a:prstGeom>
           <a:solidFill>
-            <a:srgbClr val="6366F1"/>
+            <a:srgbClr val="0F172A"/>
           </a:solidFill>
           <a:ln>
             <a:noFill/>
@@ -7611,7 +7731,7 @@
               </a:spcAft>
               <a:defRPr sz="1100" b="1">
                 <a:solidFill>
-                  <a:srgbClr val="6366F1"/>
+                  <a:srgbClr val="0F172A"/>
                 </a:solidFill>
                 <a:latin typeface="Consolas"/>
               </a:defRPr>
@@ -7627,13 +7747,13 @@
               </a:spcAft>
               <a:defRPr sz="1200" b="1">
                 <a:solidFill>
-                  <a:srgbClr val="00E5FF"/>
+                  <a:srgbClr val="0284C7"/>
                 </a:solidFill>
                 <a:latin typeface="Consolas"/>
               </a:defRPr>
             </a:pPr>
             <a:r>
-              <a:t>Maximize  SUM(x_i * EV_i)   subject to   SUM(x_i * w_i) &lt;= W_daily,   where x_i in {0, 1}</a:t>
+              <a:t>Maximize  SUM(x_i * EV_i)   subject to   SUM(x_i * w_i) &lt;= W_daily</a:t>
             </a:r>
           </a:p>
           <a:p>
@@ -7643,13 +7763,13 @@
               </a:spcAft>
               <a:defRPr sz="1200">
                 <a:solidFill>
-                  <a:srgbClr val="94A3B8"/>
+                  <a:srgbClr val="475569"/>
                 </a:solidFill>
                 <a:latin typeface="Segoe UI"/>
               </a:defRPr>
             </a:pPr>
             <a:r>
-              <a:t>Under a fixed merchant operational capacity of W = 6 effort units per day, the engine computes the global optimal subset of recovery interventions maximizing total expected yield E[V] = P(Recovered) * Amount - Action_Cost.</a:t>
+              <a:t>Under a fixed merchant operational capacity of W = 6 effort units per day, the engine computes the global optimal subset of recovery interventions maximizing total expected yield E[V] = P(Recovery) * Amount - Cost.</a:t>
             </a:r>
           </a:p>
           <a:p>
@@ -7659,7 +7779,7 @@
               </a:spcAft>
               <a:defRPr sz="1100" b="1">
                 <a:solidFill>
-                  <a:srgbClr val="10B981"/>
+                  <a:srgbClr val="059669"/>
                 </a:solidFill>
                 <a:latin typeface="Consolas"/>
               </a:defRPr>
@@ -7675,7 +7795,7 @@
               </a:spcAft>
               <a:defRPr sz="1100">
                 <a:solidFill>
-                  <a:srgbClr val="FFFFFF"/>
+                  <a:srgbClr val="0F172A"/>
                 </a:solidFill>
                 <a:latin typeface="Consolas"/>
               </a:defRPr>
@@ -7691,7 +7811,7 @@
               </a:spcAft>
               <a:defRPr sz="1100">
                 <a:solidFill>
-                  <a:srgbClr val="FFFFFF"/>
+                  <a:srgbClr val="0F172A"/>
                 </a:solidFill>
                 <a:latin typeface="Consolas"/>
               </a:defRPr>
@@ -7707,7 +7827,7 @@
               </a:spcAft>
               <a:defRPr sz="1100">
                 <a:solidFill>
-                  <a:srgbClr val="FFFFFF"/>
+                  <a:srgbClr val="0F172A"/>
                 </a:solidFill>
                 <a:latin typeface="Consolas"/>
               </a:defRPr>
@@ -7724,7 +7844,7 @@
               </a:spcAft>
               <a:defRPr sz="1100" b="1">
                 <a:solidFill>
-                  <a:srgbClr val="F43F5E"/>
+                  <a:srgbClr val="E11D48"/>
                 </a:solidFill>
                 <a:latin typeface="Consolas"/>
               </a:defRPr>
@@ -7737,13 +7857,13 @@
             <a:pPr>
               <a:defRPr sz="1100">
                 <a:solidFill>
-                  <a:srgbClr val="94A3B8"/>
+                  <a:srgbClr val="475569"/>
                 </a:solidFill>
                 <a:latin typeface="Segoe UI"/>
               </a:defRPr>
             </a:pPr>
             <a:r>
-              <a:t>  [-] INV-2026-003 (Rs 15,200) — Exceeds remaining budget (requires 2 units, 0 remaining). Lower EV-per-effort density than the chosen combination. Plain sorting would have naively picked this and lost Rs 13,000+ in other recoveries.</a:t>
+              <a:t>  [-] INV-2026-003 (Rs 15,200) — Exceeds remaining budget. Lower EV-per-effort density. Plain sorting would have naively picked this and lost Rs 13,000+ in other recoveries.</a:t>
             </a:r>
           </a:p>
         </p:txBody>
@@ -7763,11 +7883,11 @@
             <a:avLst/>
           </a:prstGeom>
           <a:solidFill>
-            <a:srgbClr val="0E192D"/>
-          </a:solidFill>
-          <a:ln w="15240">
+            <a:srgbClr val="0F172A"/>
+          </a:solidFill>
+          <a:ln w="12700">
             <a:solidFill>
-              <a:srgbClr val="00E5FF"/>
+              <a:srgbClr val="0F172A"/>
             </a:solidFill>
           </a:ln>
         </p:spPr>
@@ -7808,7 +7928,7 @@
             <a:avLst/>
           </a:prstGeom>
           <a:solidFill>
-            <a:srgbClr val="10B981"/>
+            <a:srgbClr val="059669"/>
           </a:solidFill>
           <a:ln>
             <a:noFill/>
@@ -7864,7 +7984,7 @@
               </a:spcAft>
               <a:defRPr sz="1100" b="1">
                 <a:solidFill>
-                  <a:srgbClr val="00E5FF"/>
+                  <a:srgbClr val="0284C7"/>
                 </a:solidFill>
                 <a:latin typeface="Consolas"/>
               </a:defRPr>
@@ -7880,7 +8000,7 @@
               </a:spcAft>
               <a:defRPr sz="5800" b="1">
                 <a:solidFill>
-                  <a:srgbClr val="10B981"/>
+                  <a:srgbClr val="059669"/>
                 </a:solidFill>
                 <a:latin typeface="Segoe UI"/>
               </a:defRPr>
@@ -7902,7 +8022,7 @@
               </a:defRPr>
             </a:pPr>
             <a:r>
-              <a:t>Higher expected revenue recovery compared to naive First-In-First-Out (FIFO) queue processing.</a:t>
+              <a:t>Higher expected revenue recovery compared to naive First-In-First-Out queue processing.</a:t>
             </a:r>
           </a:p>
           <a:p>
@@ -7919,7 +8039,7 @@
             </a:r>
             <a:br/>
             <a:r>
-              <a:t>Tested against synthetic ground-truth recovery sets under identical staff capacity budgets. Dynamic programming consistently unlocks the global maximum.</a:t>
+              <a:t>Tested against synthetic ground-truth recovery sets under identical staff capacity budgets.</a:t>
             </a:r>
           </a:p>
         </p:txBody>
@@ -7949,13 +8069,13 @@
             <a:pPr>
               <a:defRPr sz="900">
                 <a:solidFill>
-                  <a:srgbClr val="5A6E8C"/>
-                </a:solidFill>
-                <a:latin typeface="Consolas"/>
-              </a:defRPr>
-            </a:pPr>
-            <a:r>
-              <a:t>RecoverIQ  //  AI Revenue Recovery Opportunity Engine  |  Razorpay AI Buildathon (Track 3)  |  Slide 5 of 9</a:t>
+                  <a:srgbClr val="64748B"/>
+                </a:solidFill>
+                <a:latin typeface="Segoe UI"/>
+              </a:defRPr>
+            </a:pPr>
+            <a:r>
+              <a:t>RecoverIQ  |  AI Revenue Recovery Engine  |  Razorpay AI Buildathon  |  Slide 5 of 9</a:t>
             </a:r>
           </a:p>
         </p:txBody>
@@ -7993,7 +8113,7 @@
             <a:avLst/>
           </a:prstGeom>
           <a:solidFill>
-            <a:srgbClr val="080C16"/>
+            <a:srgbClr val="F8FAFC"/>
           </a:solidFill>
           <a:ln>
             <a:noFill/>
@@ -8030,13 +8150,13 @@
         <p:spPr>
           <a:xfrm>
             <a:off x="0" y="0"/>
-            <a:ext cx="12191695" cy="73152"/>
+            <a:ext cx="12191695" cy="54864"/>
           </a:xfrm>
           <a:prstGeom prst="rect">
             <a:avLst/>
           </a:prstGeom>
           <a:solidFill>
-            <a:srgbClr val="00E5FF"/>
+            <a:srgbClr val="0284C7"/>
           </a:solidFill>
           <a:ln>
             <a:noFill/>
@@ -8079,11 +8199,11 @@
             <a:avLst/>
           </a:prstGeom>
           <a:solidFill>
-            <a:srgbClr val="102036"/>
+            <a:srgbClr val="E0F2FE"/>
           </a:solidFill>
           <a:ln w="12700">
             <a:solidFill>
-              <a:srgbClr val="00E5FF"/>
+              <a:srgbClr val="0284C7"/>
             </a:solidFill>
           </a:ln>
         </p:spPr>
@@ -8108,7 +8228,7 @@
             <a:pPr algn="ctr">
               <a:defRPr sz="950" b="1">
                 <a:solidFill>
-                  <a:srgbClr val="00E5FF"/>
+                  <a:srgbClr val="0284C7"/>
                 </a:solidFill>
                 <a:latin typeface="Consolas"/>
               </a:defRPr>
@@ -8144,7 +8264,7 @@
             <a:pPr>
               <a:defRPr sz="2300" b="1">
                 <a:solidFill>
-                  <a:srgbClr val="FFFFFF"/>
+                  <a:srgbClr val="0F172A"/>
                 </a:solidFill>
                 <a:latin typeface="Segoe UI"/>
               </a:defRPr>
@@ -8180,13 +8300,13 @@
             <a:pPr>
               <a:defRPr sz="1300">
                 <a:solidFill>
-                  <a:srgbClr val="94A3B8"/>
+                  <a:srgbClr val="475569"/>
                 </a:solidFill>
                 <a:latin typeface="Segoe UI"/>
               </a:defRPr>
             </a:pPr>
             <a:r>
-              <a:t>Confidence is derived strictly from the calibrated statistical model — never from an unverified generative LLM hallucination.</a:t>
+              <a:t>Confidence is derived strictly from the calibrated statistical model — never from an unverified hallucination.</a:t>
             </a:r>
           </a:p>
         </p:txBody>
@@ -8206,11 +8326,11 @@
             <a:avLst/>
           </a:prstGeom>
           <a:solidFill>
-            <a:srgbClr val="10182A"/>
-          </a:solidFill>
-          <a:ln w="15240">
+            <a:srgbClr val="FFFFFF"/>
+          </a:solidFill>
+          <a:ln w="12700">
             <a:solidFill>
-              <a:srgbClr val="21304D"/>
+              <a:srgbClr val="E2E8F0"/>
             </a:solidFill>
           </a:ln>
         </p:spPr>
@@ -8251,7 +8371,7 @@
             <a:avLst/>
           </a:prstGeom>
           <a:solidFill>
-            <a:srgbClr val="10B981"/>
+            <a:srgbClr val="059669"/>
           </a:solidFill>
           <a:ln>
             <a:noFill/>
@@ -8307,7 +8427,7 @@
               </a:spcAft>
               <a:defRPr sz="1100" b="1">
                 <a:solidFill>
-                  <a:srgbClr val="10B981"/>
+                  <a:srgbClr val="059669"/>
                 </a:solidFill>
                 <a:latin typeface="Consolas"/>
               </a:defRPr>
@@ -8320,7 +8440,7 @@
             <a:pPr>
               <a:defRPr sz="1000" b="1">
                 <a:solidFill>
-                  <a:srgbClr val="00E5FF"/>
+                  <a:srgbClr val="64748B"/>
                 </a:solidFill>
                 <a:latin typeface="Consolas"/>
               </a:defRPr>
@@ -8334,9 +8454,9 @@
               <a:spcAft>
                 <a:spcPts val="500"/>
               </a:spcAft>
-              <a:defRPr sz="1150">
-                <a:solidFill>
-                  <a:srgbClr val="FFFFFF"/>
+              <a:defRPr sz="1150" b="1">
+                <a:solidFill>
+                  <a:srgbClr val="0F172A"/>
                 </a:solidFill>
                 <a:latin typeface="Segoe UI"/>
               </a:defRPr>
@@ -8349,7 +8469,7 @@
             <a:pPr>
               <a:defRPr sz="1000" b="1">
                 <a:solidFill>
-                  <a:srgbClr val="00E5FF"/>
+                  <a:srgbClr val="64748B"/>
                 </a:solidFill>
                 <a:latin typeface="Consolas"/>
               </a:defRPr>
@@ -8363,9 +8483,9 @@
               <a:spcAft>
                 <a:spcPts val="500"/>
               </a:spcAft>
-              <a:defRPr sz="1150">
-                <a:solidFill>
-                  <a:srgbClr val="FFFFFF"/>
+              <a:defRPr sz="1150" b="1">
+                <a:solidFill>
+                  <a:srgbClr val="0F172A"/>
                 </a:solidFill>
                 <a:latin typeface="Segoe UI"/>
               </a:defRPr>
@@ -8378,7 +8498,7 @@
             <a:pPr>
               <a:defRPr sz="1000" b="1">
                 <a:solidFill>
-                  <a:srgbClr val="00E5FF"/>
+                  <a:srgbClr val="64748B"/>
                 </a:solidFill>
                 <a:latin typeface="Consolas"/>
               </a:defRPr>
@@ -8392,9 +8512,9 @@
               <a:spcAft>
                 <a:spcPts val="500"/>
               </a:spcAft>
-              <a:defRPr sz="1150">
-                <a:solidFill>
-                  <a:srgbClr val="FFFFFF"/>
+              <a:defRPr sz="1150" b="1">
+                <a:solidFill>
+                  <a:srgbClr val="0F172A"/>
                 </a:solidFill>
                 <a:latin typeface="Segoe UI"/>
               </a:defRPr>
@@ -8407,7 +8527,7 @@
             <a:pPr>
               <a:defRPr sz="1000" b="1">
                 <a:solidFill>
-                  <a:srgbClr val="00E5FF"/>
+                  <a:srgbClr val="64748B"/>
                 </a:solidFill>
                 <a:latin typeface="Consolas"/>
               </a:defRPr>
@@ -8421,9 +8541,9 @@
               <a:spcAft>
                 <a:spcPts val="500"/>
               </a:spcAft>
-              <a:defRPr sz="1150">
-                <a:solidFill>
-                  <a:srgbClr val="FFFFFF"/>
+              <a:defRPr sz="1150" b="1">
+                <a:solidFill>
+                  <a:srgbClr val="0F172A"/>
                 </a:solidFill>
                 <a:latin typeface="Segoe UI"/>
               </a:defRPr>
@@ -8436,7 +8556,7 @@
             <a:pPr>
               <a:defRPr sz="1000" b="1">
                 <a:solidFill>
-                  <a:srgbClr val="00E5FF"/>
+                  <a:srgbClr val="64748B"/>
                 </a:solidFill>
                 <a:latin typeface="Consolas"/>
               </a:defRPr>
@@ -8450,22 +8570,22 @@
               <a:spcAft>
                 <a:spcPts val="500"/>
               </a:spcAft>
-              <a:defRPr sz="1150">
-                <a:solidFill>
-                  <a:srgbClr val="FFFFFF"/>
+              <a:defRPr sz="1150" b="1">
+                <a:solidFill>
+                  <a:srgbClr val="0F172A"/>
                 </a:solidFill>
                 <a:latin typeface="Segoe UI"/>
               </a:defRPr>
             </a:pPr>
             <a:r>
-              <a:t>  PASSED — Spend ceiling respected, switch latency nominal, no spam cooldown active</a:t>
+              <a:t>  PASSED — Spend ceiling respected, switch latency nominal</a:t>
             </a:r>
           </a:p>
           <a:p>
             <a:pPr>
               <a:defRPr sz="1000" b="1">
                 <a:solidFill>
-                  <a:srgbClr val="00E5FF"/>
+                  <a:srgbClr val="64748B"/>
                 </a:solidFill>
                 <a:latin typeface="Consolas"/>
               </a:defRPr>
@@ -8479,9 +8599,9 @@
               <a:spcAft>
                 <a:spcPts val="500"/>
               </a:spcAft>
-              <a:defRPr sz="1150">
-                <a:solidFill>
-                  <a:srgbClr val="FFFFFF"/>
+              <a:defRPr sz="1150" b="1">
+                <a:solidFill>
+                  <a:srgbClr val="0F172A"/>
                 </a:solidFill>
                 <a:latin typeface="Segoe UI"/>
               </a:defRPr>
@@ -8507,11 +8627,11 @@
             <a:avLst/>
           </a:prstGeom>
           <a:solidFill>
-            <a:srgbClr val="10182A"/>
-          </a:solidFill>
-          <a:ln w="15240">
+            <a:srgbClr val="FFFFFF"/>
+          </a:solidFill>
+          <a:ln w="12700">
             <a:solidFill>
-              <a:srgbClr val="21304D"/>
+              <a:srgbClr val="E2E8F0"/>
             </a:solidFill>
           </a:ln>
         </p:spPr>
@@ -8552,7 +8672,7 @@
             <a:avLst/>
           </a:prstGeom>
           <a:solidFill>
-            <a:srgbClr val="F59E0B"/>
+            <a:srgbClr val="D97706"/>
           </a:solidFill>
           <a:ln>
             <a:noFill/>
@@ -8608,7 +8728,7 @@
               </a:spcAft>
               <a:defRPr sz="1100" b="1">
                 <a:solidFill>
-                  <a:srgbClr val="F59E0B"/>
+                  <a:srgbClr val="D97706"/>
                 </a:solidFill>
                 <a:latin typeface="Consolas"/>
               </a:defRPr>
@@ -8621,7 +8741,7 @@
             <a:pPr>
               <a:defRPr sz="1000" b="1">
                 <a:solidFill>
-                  <a:srgbClr val="F59E0B"/>
+                  <a:srgbClr val="64748B"/>
                 </a:solidFill>
                 <a:latin typeface="Consolas"/>
               </a:defRPr>
@@ -8635,9 +8755,9 @@
               <a:spcAft>
                 <a:spcPts val="500"/>
               </a:spcAft>
-              <a:defRPr sz="1150">
-                <a:solidFill>
-                  <a:srgbClr val="FFFFFF"/>
+              <a:defRPr sz="1150" b="1">
+                <a:solidFill>
+                  <a:srgbClr val="0F172A"/>
                 </a:solidFill>
                 <a:latin typeface="Segoe UI"/>
               </a:defRPr>
@@ -8650,7 +8770,7 @@
             <a:pPr>
               <a:defRPr sz="1000" b="1">
                 <a:solidFill>
-                  <a:srgbClr val="F59E0B"/>
+                  <a:srgbClr val="64748B"/>
                 </a:solidFill>
                 <a:latin typeface="Consolas"/>
               </a:defRPr>
@@ -8664,9 +8784,9 @@
               <a:spcAft>
                 <a:spcPts val="500"/>
               </a:spcAft>
-              <a:defRPr sz="1150">
-                <a:solidFill>
-                  <a:srgbClr val="FFFFFF"/>
+              <a:defRPr sz="1150" b="1">
+                <a:solidFill>
+                  <a:srgbClr val="0F172A"/>
                 </a:solidFill>
                 <a:latin typeface="Segoe UI"/>
               </a:defRPr>
@@ -8679,7 +8799,7 @@
             <a:pPr>
               <a:defRPr sz="1000" b="1">
                 <a:solidFill>
-                  <a:srgbClr val="F59E0B"/>
+                  <a:srgbClr val="64748B"/>
                 </a:solidFill>
                 <a:latin typeface="Consolas"/>
               </a:defRPr>
@@ -8693,9 +8813,9 @@
               <a:spcAft>
                 <a:spcPts val="500"/>
               </a:spcAft>
-              <a:defRPr sz="1150">
-                <a:solidFill>
-                  <a:srgbClr val="FFFFFF"/>
+              <a:defRPr sz="1150" b="1">
+                <a:solidFill>
+                  <a:srgbClr val="0F172A"/>
                 </a:solidFill>
                 <a:latin typeface="Segoe UI"/>
               </a:defRPr>
@@ -8708,7 +8828,7 @@
             <a:pPr>
               <a:defRPr sz="1000" b="1">
                 <a:solidFill>
-                  <a:srgbClr val="F59E0B"/>
+                  <a:srgbClr val="64748B"/>
                 </a:solidFill>
                 <a:latin typeface="Consolas"/>
               </a:defRPr>
@@ -8722,9 +8842,9 @@
               <a:spcAft>
                 <a:spcPts val="500"/>
               </a:spcAft>
-              <a:defRPr sz="1150">
-                <a:solidFill>
-                  <a:srgbClr val="FFFFFF"/>
+              <a:defRPr sz="1150" b="1">
+                <a:solidFill>
+                  <a:srgbClr val="0F172A"/>
                 </a:solidFill>
                 <a:latin typeface="Segoe UI"/>
               </a:defRPr>
@@ -8737,7 +8857,7 @@
             <a:pPr>
               <a:defRPr sz="1000" b="1">
                 <a:solidFill>
-                  <a:srgbClr val="F59E0B"/>
+                  <a:srgbClr val="64748B"/>
                 </a:solidFill>
                 <a:latin typeface="Consolas"/>
               </a:defRPr>
@@ -8751,9 +8871,9 @@
               <a:spcAft>
                 <a:spcPts val="500"/>
               </a:spcAft>
-              <a:defRPr sz="1150">
-                <a:solidFill>
-                  <a:srgbClr val="FFFFFF"/>
+              <a:defRPr sz="1150" b="1">
+                <a:solidFill>
+                  <a:srgbClr val="0F172A"/>
                 </a:solidFill>
                 <a:latin typeface="Segoe UI"/>
               </a:defRPr>
@@ -8766,7 +8886,7 @@
             <a:pPr>
               <a:defRPr sz="1000" b="1">
                 <a:solidFill>
-                  <a:srgbClr val="F59E0B"/>
+                  <a:srgbClr val="64748B"/>
                 </a:solidFill>
                 <a:latin typeface="Consolas"/>
               </a:defRPr>
@@ -8780,15 +8900,15 @@
               <a:spcAft>
                 <a:spcPts val="500"/>
               </a:spcAft>
-              <a:defRPr sz="1150">
-                <a:solidFill>
-                  <a:srgbClr val="FFFFFF"/>
+              <a:defRPr sz="1150" b="1">
+                <a:solidFill>
+                  <a:srgbClr val="0F172A"/>
                 </a:solidFill>
                 <a:latin typeface="Segoe UI"/>
               </a:defRPr>
             </a:pPr>
             <a:r>
-              <a:t>  Quarantined. Routed to merchant admin review queue with zero automated dispatch</a:t>
+              <a:t>  Quarantined. Routed to merchant admin review queue. Zero auto-dispatch</a:t>
             </a:r>
           </a:p>
         </p:txBody>
@@ -8818,13 +8938,13 @@
             <a:pPr>
               <a:defRPr sz="900">
                 <a:solidFill>
-                  <a:srgbClr val="5A6E8C"/>
-                </a:solidFill>
-                <a:latin typeface="Consolas"/>
-              </a:defRPr>
-            </a:pPr>
-            <a:r>
-              <a:t>RecoverIQ  //  AI Revenue Recovery Opportunity Engine  |  Razorpay AI Buildathon (Track 3)  |  Slide 6 of 9</a:t>
+                  <a:srgbClr val="64748B"/>
+                </a:solidFill>
+                <a:latin typeface="Segoe UI"/>
+              </a:defRPr>
+            </a:pPr>
+            <a:r>
+              <a:t>RecoverIQ  |  AI Revenue Recovery Engine  |  Razorpay AI Buildathon  |  Slide 6 of 9</a:t>
             </a:r>
           </a:p>
         </p:txBody>
@@ -8862,7 +8982,7 @@
             <a:avLst/>
           </a:prstGeom>
           <a:solidFill>
-            <a:srgbClr val="080C16"/>
+            <a:srgbClr val="F8FAFC"/>
           </a:solidFill>
           <a:ln>
             <a:noFill/>
@@ -8899,13 +9019,13 @@
         <p:spPr>
           <a:xfrm>
             <a:off x="0" y="0"/>
-            <a:ext cx="12191695" cy="73152"/>
+            <a:ext cx="12191695" cy="54864"/>
           </a:xfrm>
           <a:prstGeom prst="rect">
             <a:avLst/>
           </a:prstGeom>
           <a:solidFill>
-            <a:srgbClr val="00E5FF"/>
+            <a:srgbClr val="0284C7"/>
           </a:solidFill>
           <a:ln>
             <a:noFill/>
@@ -8948,11 +9068,11 @@
             <a:avLst/>
           </a:prstGeom>
           <a:solidFill>
-            <a:srgbClr val="102036"/>
+            <a:srgbClr val="E0F2FE"/>
           </a:solidFill>
           <a:ln w="12700">
             <a:solidFill>
-              <a:srgbClr val="00E5FF"/>
+              <a:srgbClr val="0284C7"/>
             </a:solidFill>
           </a:ln>
         </p:spPr>
@@ -8977,7 +9097,7 @@
             <a:pPr algn="ctr">
               <a:defRPr sz="950" b="1">
                 <a:solidFill>
-                  <a:srgbClr val="00E5FF"/>
+                  <a:srgbClr val="0284C7"/>
                 </a:solidFill>
                 <a:latin typeface="Consolas"/>
               </a:defRPr>
@@ -9013,7 +9133,7 @@
             <a:pPr>
               <a:defRPr sz="2300" b="1">
                 <a:solidFill>
-                  <a:srgbClr val="FFFFFF"/>
+                  <a:srgbClr val="0F172A"/>
                 </a:solidFill>
                 <a:latin typeface="Segoe UI"/>
               </a:defRPr>
@@ -9049,7 +9169,7 @@
             <a:pPr>
               <a:defRPr sz="1300">
                 <a:solidFill>
-                  <a:srgbClr val="94A3B8"/>
+                  <a:srgbClr val="475569"/>
                 </a:solidFill>
                 <a:latin typeface="Segoe UI"/>
               </a:defRPr>
@@ -9075,11 +9195,11 @@
             <a:avLst/>
           </a:prstGeom>
           <a:solidFill>
-            <a:srgbClr val="10182A"/>
-          </a:solidFill>
-          <a:ln w="15240">
+            <a:srgbClr val="FFFFFF"/>
+          </a:solidFill>
+          <a:ln w="12700">
             <a:solidFill>
-              <a:srgbClr val="21304D"/>
+              <a:srgbClr val="E2E8F0"/>
             </a:solidFill>
           </a:ln>
         </p:spPr>
@@ -9120,7 +9240,7 @@
             <a:avLst/>
           </a:prstGeom>
           <a:solidFill>
-            <a:srgbClr val="F43F5E"/>
+            <a:srgbClr val="E11D48"/>
           </a:solidFill>
           <a:ln>
             <a:noFill/>
@@ -9176,7 +9296,7 @@
               </a:spcAft>
               <a:defRPr sz="900" b="1">
                 <a:solidFill>
-                  <a:srgbClr val="F43F5E"/>
+                  <a:srgbClr val="E11D48"/>
                 </a:solidFill>
                 <a:latin typeface="Consolas"/>
               </a:defRPr>
@@ -9192,7 +9312,7 @@
               </a:spcAft>
               <a:defRPr sz="2800" b="1">
                 <a:solidFill>
-                  <a:srgbClr val="FFFFFF"/>
+                  <a:srgbClr val="0F172A"/>
                 </a:solidFill>
                 <a:latin typeface="Segoe UI"/>
               </a:defRPr>
@@ -9205,7 +9325,7 @@
             <a:pPr>
               <a:defRPr sz="1100">
                 <a:solidFill>
-                  <a:srgbClr val="94A3B8"/>
+                  <a:srgbClr val="475569"/>
                 </a:solidFill>
                 <a:latin typeface="Segoe UI"/>
               </a:defRPr>
@@ -9231,11 +9351,11 @@
             <a:avLst/>
           </a:prstGeom>
           <a:solidFill>
-            <a:srgbClr val="10182A"/>
-          </a:solidFill>
-          <a:ln w="15240">
+            <a:srgbClr val="FFFFFF"/>
+          </a:solidFill>
+          <a:ln w="12700">
             <a:solidFill>
-              <a:srgbClr val="21304D"/>
+              <a:srgbClr val="E2E8F0"/>
             </a:solidFill>
           </a:ln>
         </p:spPr>
@@ -9276,7 +9396,7 @@
             <a:avLst/>
           </a:prstGeom>
           <a:solidFill>
-            <a:srgbClr val="3395FF"/>
+            <a:srgbClr val="0066FF"/>
           </a:solidFill>
           <a:ln>
             <a:noFill/>
@@ -9332,7 +9452,7 @@
               </a:spcAft>
               <a:defRPr sz="900" b="1">
                 <a:solidFill>
-                  <a:srgbClr val="3395FF"/>
+                  <a:srgbClr val="0066FF"/>
                 </a:solidFill>
                 <a:latin typeface="Consolas"/>
               </a:defRPr>
@@ -9348,7 +9468,7 @@
               </a:spcAft>
               <a:defRPr sz="2800" b="1">
                 <a:solidFill>
-                  <a:srgbClr val="FFFFFF"/>
+                  <a:srgbClr val="0F172A"/>
                 </a:solidFill>
                 <a:latin typeface="Segoe UI"/>
               </a:defRPr>
@@ -9361,7 +9481,7 @@
             <a:pPr>
               <a:defRPr sz="1100">
                 <a:solidFill>
-                  <a:srgbClr val="94A3B8"/>
+                  <a:srgbClr val="475569"/>
                 </a:solidFill>
                 <a:latin typeface="Segoe UI"/>
               </a:defRPr>
@@ -9387,11 +9507,11 @@
             <a:avLst/>
           </a:prstGeom>
           <a:solidFill>
-            <a:srgbClr val="10182A"/>
-          </a:solidFill>
-          <a:ln w="15240">
+            <a:srgbClr val="FFFFFF"/>
+          </a:solidFill>
+          <a:ln w="12700">
             <a:solidFill>
-              <a:srgbClr val="21304D"/>
+              <a:srgbClr val="E2E8F0"/>
             </a:solidFill>
           </a:ln>
         </p:spPr>
@@ -9432,7 +9552,7 @@
             <a:avLst/>
           </a:prstGeom>
           <a:solidFill>
-            <a:srgbClr val="10B981"/>
+            <a:srgbClr val="059669"/>
           </a:solidFill>
           <a:ln>
             <a:noFill/>
@@ -9488,7 +9608,7 @@
               </a:spcAft>
               <a:defRPr sz="900" b="1">
                 <a:solidFill>
-                  <a:srgbClr val="10B981"/>
+                  <a:srgbClr val="059669"/>
                 </a:solidFill>
                 <a:latin typeface="Consolas"/>
               </a:defRPr>
@@ -9504,7 +9624,7 @@
               </a:spcAft>
               <a:defRPr sz="2800" b="1">
                 <a:solidFill>
-                  <a:srgbClr val="FFFFFF"/>
+                  <a:srgbClr val="0F172A"/>
                 </a:solidFill>
                 <a:latin typeface="Segoe UI"/>
               </a:defRPr>
@@ -9517,7 +9637,7 @@
             <a:pPr>
               <a:defRPr sz="1100">
                 <a:solidFill>
-                  <a:srgbClr val="94A3B8"/>
+                  <a:srgbClr val="475569"/>
                 </a:solidFill>
                 <a:latin typeface="Segoe UI"/>
               </a:defRPr>
@@ -9543,11 +9663,11 @@
             <a:avLst/>
           </a:prstGeom>
           <a:solidFill>
-            <a:srgbClr val="10182A"/>
-          </a:solidFill>
-          <a:ln w="15240">
+            <a:srgbClr val="FFFFFF"/>
+          </a:solidFill>
+          <a:ln w="12700">
             <a:solidFill>
-              <a:srgbClr val="21304D"/>
+              <a:srgbClr val="E2E8F0"/>
             </a:solidFill>
           </a:ln>
         </p:spPr>
@@ -9588,7 +9708,7 @@
             <a:avLst/>
           </a:prstGeom>
           <a:solidFill>
-            <a:srgbClr val="00E5FF"/>
+            <a:srgbClr val="0284C7"/>
           </a:solidFill>
           <a:ln>
             <a:noFill/>
@@ -9644,7 +9764,7 @@
               </a:spcAft>
               <a:defRPr sz="900" b="1">
                 <a:solidFill>
-                  <a:srgbClr val="00E5FF"/>
+                  <a:srgbClr val="0284C7"/>
                 </a:solidFill>
                 <a:latin typeface="Consolas"/>
               </a:defRPr>
@@ -9660,7 +9780,7 @@
               </a:spcAft>
               <a:defRPr sz="2800" b="1">
                 <a:solidFill>
-                  <a:srgbClr val="FFFFFF"/>
+                  <a:srgbClr val="0F172A"/>
                 </a:solidFill>
                 <a:latin typeface="Segoe UI"/>
               </a:defRPr>
@@ -9673,7 +9793,7 @@
             <a:pPr>
               <a:defRPr sz="1100">
                 <a:solidFill>
-                  <a:srgbClr val="94A3B8"/>
+                  <a:srgbClr val="475569"/>
                 </a:solidFill>
                 <a:latin typeface="Segoe UI"/>
               </a:defRPr>
@@ -9699,11 +9819,11 @@
             <a:avLst/>
           </a:prstGeom>
           <a:solidFill>
-            <a:srgbClr val="10182A"/>
-          </a:solidFill>
-          <a:ln w="15240">
+            <a:srgbClr val="FFFFFF"/>
+          </a:solidFill>
+          <a:ln w="12700">
             <a:solidFill>
-              <a:srgbClr val="21304D"/>
+              <a:srgbClr val="E2E8F0"/>
             </a:solidFill>
           </a:ln>
         </p:spPr>
@@ -9744,7 +9864,7 @@
             <a:avLst/>
           </a:prstGeom>
           <a:solidFill>
-            <a:srgbClr val="00E5FF"/>
+            <a:srgbClr val="0284C7"/>
           </a:solidFill>
           <a:ln>
             <a:noFill/>
@@ -9800,7 +9920,7 @@
               </a:spcAft>
               <a:defRPr sz="1100" b="1">
                 <a:solidFill>
-                  <a:srgbClr val="00E5FF"/>
+                  <a:srgbClr val="0284C7"/>
                 </a:solidFill>
                 <a:latin typeface="Consolas"/>
               </a:defRPr>
@@ -9816,13 +9936,13 @@
               </a:spcAft>
               <a:defRPr sz="1150">
                 <a:solidFill>
-                  <a:srgbClr val="94A3B8"/>
+                  <a:srgbClr val="475569"/>
                 </a:solidFill>
                 <a:latin typeface="Segoe UI"/>
               </a:defRPr>
             </a:pPr>
             <a:r>
-              <a:t>  *  Failed Checkouts [100.0%]:  Instant switch failover retries and 1-click fallback links captured immediate bank card decline recoverables.</a:t>
+              <a:t>  •  Failed Checkouts [100.0%]:  Instant switch failover retries and 1-click fallback links captured immediate bank card decline recoverables.</a:t>
             </a:r>
           </a:p>
           <a:p>
@@ -9832,13 +9952,13 @@
               </a:spcAft>
               <a:defRPr sz="1150">
                 <a:solidFill>
-                  <a:srgbClr val="94A3B8"/>
+                  <a:srgbClr val="475569"/>
                 </a:solidFill>
                 <a:latin typeface="Segoe UI"/>
               </a:defRPr>
             </a:pPr>
             <a:r>
-              <a:t>  *  Partial Payments [37.8%]:  Automated WhatsApp and SMS dunning links with tailored expiry successfully converted abandoned installments.</a:t>
+              <a:t>  •  Partial Payments [37.8%]:  Automated WhatsApp and SMS dunning links with tailored expiry successfully converted abandoned installments.</a:t>
             </a:r>
           </a:p>
           <a:p>
@@ -9848,13 +9968,13 @@
               </a:spcAft>
               <a:defRPr sz="1150">
                 <a:solidFill>
-                  <a:srgbClr val="94A3B8"/>
+                  <a:srgbClr val="475569"/>
                 </a:solidFill>
                 <a:latin typeface="Segoe UI"/>
               </a:defRPr>
             </a:pPr>
             <a:r>
-              <a:t>  *  Overdue Invoices [Active / In Progress]:  B2B commercial invoice payment links generated with unique reference tracking and automated reminder intervals.</a:t>
+              <a:t>  •  Overdue Invoices [Active]:  B2B commercial invoice payment links generated with unique reference tracking and automated reminder intervals.</a:t>
             </a:r>
           </a:p>
           <a:p>
@@ -9864,13 +9984,13 @@
               </a:spcAft>
               <a:defRPr sz="1150">
                 <a:solidFill>
-                  <a:srgbClr val="94A3B8"/>
+                  <a:srgbClr val="475569"/>
                 </a:solidFill>
                 <a:latin typeface="Segoe UI"/>
               </a:defRPr>
             </a:pPr>
             <a:r>
-              <a:t>  *  Refund Mismatches [Reconciled]:  Pre-authorization capture executed safely within the deterministic Rs 7,500 safety threshold.</a:t>
+              <a:t>  •  Refund Mismatches [Reconciled]:  Pre-authorization capture executed safely within the deterministic Rs 7,500 safety threshold.</a:t>
             </a:r>
           </a:p>
         </p:txBody>
@@ -9900,13 +10020,13 @@
             <a:pPr>
               <a:defRPr sz="900">
                 <a:solidFill>
-                  <a:srgbClr val="5A6E8C"/>
-                </a:solidFill>
-                <a:latin typeface="Consolas"/>
-              </a:defRPr>
-            </a:pPr>
-            <a:r>
-              <a:t>RecoverIQ  //  AI Revenue Recovery Opportunity Engine  |  Razorpay AI Buildathon (Track 3)  |  Slide 7 of 9</a:t>
+                  <a:srgbClr val="64748B"/>
+                </a:solidFill>
+                <a:latin typeface="Segoe UI"/>
+              </a:defRPr>
+            </a:pPr>
+            <a:r>
+              <a:t>RecoverIQ  |  AI Revenue Recovery Engine  |  Razorpay AI Buildathon  |  Slide 7 of 9</a:t>
             </a:r>
           </a:p>
         </p:txBody>
@@ -9944,7 +10064,7 @@
             <a:avLst/>
           </a:prstGeom>
           <a:solidFill>
-            <a:srgbClr val="080C16"/>
+            <a:srgbClr val="F8FAFC"/>
           </a:solidFill>
           <a:ln>
             <a:noFill/>
@@ -9981,13 +10101,13 @@
         <p:spPr>
           <a:xfrm>
             <a:off x="0" y="0"/>
-            <a:ext cx="12191695" cy="73152"/>
+            <a:ext cx="12191695" cy="54864"/>
           </a:xfrm>
           <a:prstGeom prst="rect">
             <a:avLst/>
           </a:prstGeom>
           <a:solidFill>
-            <a:srgbClr val="00E5FF"/>
+            <a:srgbClr val="0284C7"/>
           </a:solidFill>
           <a:ln>
             <a:noFill/>
@@ -10024,17 +10144,17 @@
         <p:spPr>
           <a:xfrm>
             <a:off x="731520" y="384048"/>
-            <a:ext cx="2788920" cy="292608"/>
+            <a:ext cx="1700784" cy="292608"/>
           </a:xfrm>
           <a:prstGeom prst="roundRect">
             <a:avLst/>
           </a:prstGeom>
           <a:solidFill>
-            <a:srgbClr val="102036"/>
+            <a:srgbClr val="E0F2FE"/>
           </a:solidFill>
           <a:ln w="12700">
             <a:solidFill>
-              <a:srgbClr val="00E5FF"/>
+              <a:srgbClr val="0284C7"/>
             </a:solidFill>
           </a:ln>
         </p:spPr>
@@ -10059,13 +10179,13 @@
             <a:pPr algn="ctr">
               <a:defRPr sz="950" b="1">
                 <a:solidFill>
-                  <a:srgbClr val="00E5FF"/>
+                  <a:srgbClr val="0284C7"/>
                 </a:solidFill>
                 <a:latin typeface="Consolas"/>
               </a:defRPr>
             </a:pPr>
             <a:r>
-              <a:t>MODEL CALIBRATION &amp; BENCHMARKS</a:t>
+              <a:t>MODEL BENCHMARKS</a:t>
             </a:r>
           </a:p>
         </p:txBody>
@@ -10095,7 +10215,7 @@
             <a:pPr>
               <a:defRPr sz="2300" b="1">
                 <a:solidFill>
-                  <a:srgbClr val="FFFFFF"/>
+                  <a:srgbClr val="0F172A"/>
                 </a:solidFill>
                 <a:latin typeface="Segoe UI"/>
               </a:defRPr>
@@ -10131,13 +10251,13 @@
             <a:pPr>
               <a:defRPr sz="1300">
                 <a:solidFill>
-                  <a:srgbClr val="94A3B8"/>
+                  <a:srgbClr val="475569"/>
                 </a:solidFill>
                 <a:latin typeface="Segoe UI"/>
               </a:defRPr>
             </a:pPr>
             <a:r>
-              <a:t>Evaluating predictive discrimination, empirical reliability, and high-concurrency production architecture.</a:t>
+              <a:t>Evaluating predictive discrimination, empirical reliability, and production architecture.</a:t>
             </a:r>
           </a:p>
         </p:txBody>
@@ -10157,11 +10277,11 @@
             <a:avLst/>
           </a:prstGeom>
           <a:solidFill>
-            <a:srgbClr val="10182A"/>
-          </a:solidFill>
-          <a:ln w="15240">
+            <a:srgbClr val="FFFFFF"/>
+          </a:solidFill>
+          <a:ln w="12700">
             <a:solidFill>
-              <a:srgbClr val="21304D"/>
+              <a:srgbClr val="E2E8F0"/>
             </a:solidFill>
           </a:ln>
         </p:spPr>
@@ -10202,7 +10322,7 @@
             <a:avLst/>
           </a:prstGeom>
           <a:solidFill>
-            <a:srgbClr val="00E5FF"/>
+            <a:srgbClr val="0284C7"/>
           </a:solidFill>
           <a:ln>
             <a:noFill/>
@@ -10258,7 +10378,7 @@
               </a:spcAft>
               <a:defRPr sz="1100" b="1">
                 <a:solidFill>
-                  <a:srgbClr val="00E5FF"/>
+                  <a:srgbClr val="0284C7"/>
                 </a:solidFill>
                 <a:latin typeface="Consolas"/>
               </a:defRPr>
@@ -10271,7 +10391,7 @@
             <a:pPr>
               <a:defRPr sz="1800" b="1">
                 <a:solidFill>
-                  <a:srgbClr val="10B981"/>
+                  <a:srgbClr val="059669"/>
                 </a:solidFill>
                 <a:latin typeface="Consolas"/>
               </a:defRPr>
@@ -10287,7 +10407,7 @@
               </a:spcAft>
               <a:defRPr sz="1100">
                 <a:solidFill>
-                  <a:srgbClr val="94A3B8"/>
+                  <a:srgbClr val="475569"/>
                 </a:solidFill>
                 <a:latin typeface="Segoe UI"/>
               </a:defRPr>
@@ -10300,7 +10420,7 @@
             <a:pPr>
               <a:defRPr sz="1800" b="1">
                 <a:solidFill>
-                  <a:srgbClr val="10B981"/>
+                  <a:srgbClr val="059669"/>
                 </a:solidFill>
                 <a:latin typeface="Consolas"/>
               </a:defRPr>
@@ -10316,7 +10436,7 @@
               </a:spcAft>
               <a:defRPr sz="1100">
                 <a:solidFill>
-                  <a:srgbClr val="94A3B8"/>
+                  <a:srgbClr val="475569"/>
                 </a:solidFill>
                 <a:latin typeface="Segoe UI"/>
               </a:defRPr>
@@ -10329,7 +10449,7 @@
             <a:pPr>
               <a:defRPr sz="1800" b="1">
                 <a:solidFill>
-                  <a:srgbClr val="10B981"/>
+                  <a:srgbClr val="059669"/>
                 </a:solidFill>
                 <a:latin typeface="Consolas"/>
               </a:defRPr>
@@ -10345,20 +10465,20 @@
               </a:spcAft>
               <a:defRPr sz="1100">
                 <a:solidFill>
-                  <a:srgbClr val="94A3B8"/>
+                  <a:srgbClr val="475569"/>
                 </a:solidFill>
                 <a:latin typeface="Segoe UI"/>
               </a:defRPr>
             </a:pPr>
             <a:r>
-              <a:t>  Discriminative separation capability on noisy payment signals</a:t>
+              <a:t>  Discriminative separation capability on noisy signals</a:t>
             </a:r>
           </a:p>
           <a:p>
             <a:pPr>
               <a:defRPr sz="1800" b="1">
                 <a:solidFill>
-                  <a:srgbClr val="10B981"/>
+                  <a:srgbClr val="059669"/>
                 </a:solidFill>
                 <a:latin typeface="Consolas"/>
               </a:defRPr>
@@ -10374,26 +10494,26 @@
               </a:spcAft>
               <a:defRPr sz="1100">
                 <a:solidFill>
-                  <a:srgbClr val="94A3B8"/>
+                  <a:srgbClr val="475569"/>
                 </a:solidFill>
                 <a:latin typeface="Segoe UI"/>
               </a:defRPr>
             </a:pPr>
             <a:r>
-              <a:t>  Low probability calibration error verified across deciles</a:t>
+              <a:t>  Low probability calibration error across deciles</a:t>
             </a:r>
           </a:p>
           <a:p>
             <a:pPr>
               <a:defRPr sz="1100">
                 <a:solidFill>
-                  <a:srgbClr val="BAE6FD"/>
+                  <a:srgbClr val="64748B"/>
                 </a:solidFill>
                 <a:latin typeface="Segoe UI"/>
               </a:defRPr>
             </a:pPr>
             <a:r>
-              <a:t>Design Decision: Recall was prioritized intentionally. In delinquent revenue recovery, missing a recoverable payment incurs a 100% loss of that capital, whereas a false-positive outreach only incurs a marginal message cost (Rs 4.00).</a:t>
+              <a:t>Design Decision: Recall was prioritized intentionally. In delinquent revenue recovery, missing a recoverable payment incurs a 100% loss of that capital, whereas a false-positive outreach only costs Rs 4.00.</a:t>
             </a:r>
           </a:p>
         </p:txBody>
@@ -10413,11 +10533,11 @@
             <a:avLst/>
           </a:prstGeom>
           <a:solidFill>
-            <a:srgbClr val="10182A"/>
-          </a:solidFill>
-          <a:ln w="15240">
+            <a:srgbClr val="FFFFFF"/>
+          </a:solidFill>
+          <a:ln w="12700">
             <a:solidFill>
-              <a:srgbClr val="21304D"/>
+              <a:srgbClr val="E2E8F0"/>
             </a:solidFill>
           </a:ln>
         </p:spPr>
@@ -10458,7 +10578,7 @@
             <a:avLst/>
           </a:prstGeom>
           <a:solidFill>
-            <a:srgbClr val="3395FF"/>
+            <a:srgbClr val="0066FF"/>
           </a:solidFill>
           <a:ln>
             <a:noFill/>
@@ -10514,7 +10634,7 @@
               </a:spcAft>
               <a:defRPr sz="1100" b="1">
                 <a:solidFill>
-                  <a:srgbClr val="3395FF"/>
+                  <a:srgbClr val="0066FF"/>
                 </a:solidFill>
                 <a:latin typeface="Consolas"/>
               </a:defRPr>
@@ -10527,13 +10647,13 @@
             <a:pPr>
               <a:defRPr sz="1200" b="1">
                 <a:solidFill>
-                  <a:srgbClr val="00E5FF"/>
+                  <a:srgbClr val="0284C7"/>
                 </a:solidFill>
                 <a:latin typeface="Consolas"/>
               </a:defRPr>
             </a:pPr>
             <a:r>
-              <a:t>[*]  FastAPI &amp; Async SQLite</a:t>
+              <a:t>•  FastAPI &amp; Async SQLite</a:t>
             </a:r>
           </a:p>
           <a:p>
@@ -10543,7 +10663,7 @@
               </a:spcAft>
               <a:defRPr sz="1100">
                 <a:solidFill>
-                  <a:srgbClr val="94A3B8"/>
+                  <a:srgbClr val="475569"/>
                 </a:solidFill>
                 <a:latin typeface="Segoe UI"/>
               </a:defRPr>
@@ -10556,13 +10676,13 @@
             <a:pPr>
               <a:defRPr sz="1200" b="1">
                 <a:solidFill>
-                  <a:srgbClr val="00E5FF"/>
+                  <a:srgbClr val="0284C7"/>
                 </a:solidFill>
                 <a:latin typeface="Consolas"/>
               </a:defRPr>
             </a:pPr>
             <a:r>
-              <a:t>[*]  scikit-learn GBDT &amp; Calibration</a:t>
+              <a:t>•  scikit-learn GBDT &amp; Calibration</a:t>
             </a:r>
           </a:p>
           <a:p>
@@ -10572,7 +10692,7 @@
               </a:spcAft>
               <a:defRPr sz="1100">
                 <a:solidFill>
-                  <a:srgbClr val="94A3B8"/>
+                  <a:srgbClr val="475569"/>
                 </a:solidFill>
                 <a:latin typeface="Segoe UI"/>
               </a:defRPr>
@@ -10585,13 +10705,13 @@
             <a:pPr>
               <a:defRPr sz="1200" b="1">
                 <a:solidFill>
-                  <a:srgbClr val="00E5FF"/>
+                  <a:srgbClr val="0284C7"/>
                 </a:solidFill>
                 <a:latin typeface="Consolas"/>
               </a:defRPr>
             </a:pPr>
             <a:r>
-              <a:t>[*]  Razorpay SDK &amp; Cloud Sync</a:t>
+              <a:t>•  Razorpay SDK &amp; Cloud Sync</a:t>
             </a:r>
           </a:p>
           <a:p>
@@ -10601,7 +10721,7 @@
               </a:spcAft>
               <a:defRPr sz="1100">
                 <a:solidFill>
-                  <a:srgbClr val="94A3B8"/>
+                  <a:srgbClr val="475569"/>
                 </a:solidFill>
                 <a:latin typeface="Segoe UI"/>
               </a:defRPr>
@@ -10614,13 +10734,13 @@
             <a:pPr>
               <a:defRPr sz="1200" b="1">
                 <a:solidFill>
-                  <a:srgbClr val="00E5FF"/>
+                  <a:srgbClr val="0284C7"/>
                 </a:solidFill>
                 <a:latin typeface="Consolas"/>
               </a:defRPr>
             </a:pPr>
             <a:r>
-              <a:t>[*]  Security &amp; Idempotency</a:t>
+              <a:t>•  Security &amp; Idempotency</a:t>
             </a:r>
           </a:p>
           <a:p>
@@ -10630,7 +10750,7 @@
               </a:spcAft>
               <a:defRPr sz="1100">
                 <a:solidFill>
-                  <a:srgbClr val="94A3B8"/>
+                  <a:srgbClr val="475569"/>
                 </a:solidFill>
                 <a:latin typeface="Segoe UI"/>
               </a:defRPr>
@@ -10666,13 +10786,13 @@
             <a:pPr>
               <a:defRPr sz="900">
                 <a:solidFill>
-                  <a:srgbClr val="5A6E8C"/>
-                </a:solidFill>
-                <a:latin typeface="Consolas"/>
-              </a:defRPr>
-            </a:pPr>
-            <a:r>
-              <a:t>RecoverIQ  //  AI Revenue Recovery Opportunity Engine  |  Razorpay AI Buildathon (Track 3)  |  Slide 8 of 9</a:t>
+                  <a:srgbClr val="64748B"/>
+                </a:solidFill>
+                <a:latin typeface="Segoe UI"/>
+              </a:defRPr>
+            </a:pPr>
+            <a:r>
+              <a:t>RecoverIQ  |  AI Revenue Recovery Engine  |  Razorpay AI Buildathon  |  Slide 8 of 9</a:t>
             </a:r>
           </a:p>
         </p:txBody>
@@ -10710,7 +10830,7 @@
             <a:avLst/>
           </a:prstGeom>
           <a:solidFill>
-            <a:srgbClr val="080C16"/>
+            <a:srgbClr val="F8FAFC"/>
           </a:solidFill>
           <a:ln>
             <a:noFill/>
@@ -10747,13 +10867,13 @@
         <p:spPr>
           <a:xfrm>
             <a:off x="0" y="0"/>
-            <a:ext cx="12191695" cy="73152"/>
+            <a:ext cx="12191695" cy="54864"/>
           </a:xfrm>
           <a:prstGeom prst="rect">
             <a:avLst/>
           </a:prstGeom>
           <a:solidFill>
-            <a:srgbClr val="00E5FF"/>
+            <a:srgbClr val="0284C7"/>
           </a:solidFill>
           <a:ln>
             <a:noFill/>
@@ -10796,11 +10916,11 @@
             <a:avLst/>
           </a:prstGeom>
           <a:solidFill>
-            <a:srgbClr val="102036"/>
+            <a:srgbClr val="E0F2FE"/>
           </a:solidFill>
           <a:ln w="12700">
             <a:solidFill>
-              <a:srgbClr val="00E5FF"/>
+              <a:srgbClr val="0284C7"/>
             </a:solidFill>
           </a:ln>
         </p:spPr>
@@ -10825,7 +10945,7 @@
             <a:pPr algn="ctr">
               <a:defRPr sz="950" b="1">
                 <a:solidFill>
-                  <a:srgbClr val="00E5FF"/>
+                  <a:srgbClr val="0284C7"/>
                 </a:solidFill>
                 <a:latin typeface="Consolas"/>
               </a:defRPr>
@@ -10861,7 +10981,7 @@
             <a:pPr>
               <a:defRPr sz="2300" b="1">
                 <a:solidFill>
-                  <a:srgbClr val="FFFFFF"/>
+                  <a:srgbClr val="0F172A"/>
                 </a:solidFill>
                 <a:latin typeface="Segoe UI"/>
               </a:defRPr>
@@ -10897,7 +11017,7 @@
             <a:pPr>
               <a:defRPr sz="1300">
                 <a:solidFill>
-                  <a:srgbClr val="94A3B8"/>
+                  <a:srgbClr val="475569"/>
                 </a:solidFill>
                 <a:latin typeface="Segoe UI"/>
               </a:defRPr>
@@ -10923,11 +11043,11 @@
             <a:avLst/>
           </a:prstGeom>
           <a:solidFill>
-            <a:srgbClr val="10182A"/>
-          </a:solidFill>
-          <a:ln w="15240">
+            <a:srgbClr val="FFFFFF"/>
+          </a:solidFill>
+          <a:ln w="12700">
             <a:solidFill>
-              <a:srgbClr val="21304D"/>
+              <a:srgbClr val="E2E8F0"/>
             </a:solidFill>
           </a:ln>
         </p:spPr>
@@ -10968,7 +11088,7 @@
             <a:avLst/>
           </a:prstGeom>
           <a:solidFill>
-            <a:srgbClr val="00E5FF"/>
+            <a:srgbClr val="0284C7"/>
           </a:solidFill>
           <a:ln>
             <a:noFill/>
@@ -11005,7 +11125,7 @@
         <p:spPr>
           <a:xfrm>
             <a:off x="896112" y="1965960"/>
-            <a:ext cx="3127248" cy="4069080"/>
+            <a:ext cx="3127248" cy="2880360"/>
           </a:xfrm>
           <a:prstGeom prst="rect">
             <a:avLst/>
@@ -11024,7 +11144,7 @@
               </a:spcAft>
               <a:defRPr sz="950" b="1">
                 <a:solidFill>
-                  <a:srgbClr val="00E5FF"/>
+                  <a:srgbClr val="0284C7"/>
                 </a:solidFill>
                 <a:latin typeface="Consolas"/>
               </a:defRPr>
@@ -11040,7 +11160,7 @@
               </a:spcAft>
               <a:defRPr sz="1700" b="1">
                 <a:solidFill>
-                  <a:srgbClr val="FFFFFF"/>
+                  <a:srgbClr val="0F172A"/>
                 </a:solidFill>
                 <a:latin typeface="Segoe UI"/>
               </a:defRPr>
@@ -11053,7 +11173,7 @@
             <a:pPr>
               <a:defRPr sz="1200">
                 <a:solidFill>
-                  <a:srgbClr val="94A3B8"/>
+                  <a:srgbClr val="475569"/>
                 </a:solidFill>
                 <a:latin typeface="Segoe UI"/>
               </a:defRPr>
@@ -11079,11 +11199,11 @@
             <a:avLst/>
           </a:prstGeom>
           <a:solidFill>
-            <a:srgbClr val="10182A"/>
-          </a:solidFill>
-          <a:ln w="15240">
+            <a:srgbClr val="FFFFFF"/>
+          </a:solidFill>
+          <a:ln w="12700">
             <a:solidFill>
-              <a:srgbClr val="21304D"/>
+              <a:srgbClr val="E2E8F0"/>
             </a:solidFill>
           </a:ln>
         </p:spPr>
@@ -11124,7 +11244,7 @@
             <a:avLst/>
           </a:prstGeom>
           <a:solidFill>
-            <a:srgbClr val="6366F1"/>
+            <a:srgbClr val="0F172A"/>
           </a:solidFill>
           <a:ln>
             <a:noFill/>
@@ -11161,7 +11281,7 @@
         <p:spPr>
           <a:xfrm>
             <a:off x="4535424" y="1965960"/>
-            <a:ext cx="3127248" cy="4069080"/>
+            <a:ext cx="3127248" cy="2880360"/>
           </a:xfrm>
           <a:prstGeom prst="rect">
             <a:avLst/>
@@ -11180,7 +11300,7 @@
               </a:spcAft>
               <a:defRPr sz="950" b="1">
                 <a:solidFill>
-                  <a:srgbClr val="6366F1"/>
+                  <a:srgbClr val="0F172A"/>
                 </a:solidFill>
                 <a:latin typeface="Consolas"/>
               </a:defRPr>
@@ -11196,7 +11316,7 @@
               </a:spcAft>
               <a:defRPr sz="1700" b="1">
                 <a:solidFill>
-                  <a:srgbClr val="FFFFFF"/>
+                  <a:srgbClr val="0F172A"/>
                 </a:solidFill>
                 <a:latin typeface="Segoe UI"/>
               </a:defRPr>
@@ -11209,7 +11329,7 @@
             <a:pPr>
               <a:defRPr sz="1200">
                 <a:solidFill>
-                  <a:srgbClr val="94A3B8"/>
+                  <a:srgbClr val="475569"/>
                 </a:solidFill>
                 <a:latin typeface="Segoe UI"/>
               </a:defRPr>
@@ -11235,11 +11355,11 @@
             <a:avLst/>
           </a:prstGeom>
           <a:solidFill>
-            <a:srgbClr val="10182A"/>
-          </a:solidFill>
-          <a:ln w="15240">
+            <a:srgbClr val="FFFFFF"/>
+          </a:solidFill>
+          <a:ln w="12700">
             <a:solidFill>
-              <a:srgbClr val="21304D"/>
+              <a:srgbClr val="E2E8F0"/>
             </a:solidFill>
           </a:ln>
         </p:spPr>
@@ -11280,7 +11400,7 @@
             <a:avLst/>
           </a:prstGeom>
           <a:solidFill>
-            <a:srgbClr val="10B981"/>
+            <a:srgbClr val="059669"/>
           </a:solidFill>
           <a:ln>
             <a:noFill/>
@@ -11317,7 +11437,7 @@
         <p:spPr>
           <a:xfrm>
             <a:off x="8174736" y="1965960"/>
-            <a:ext cx="3127248" cy="4069080"/>
+            <a:ext cx="3127248" cy="2880360"/>
           </a:xfrm>
           <a:prstGeom prst="rect">
             <a:avLst/>
@@ -11336,7 +11456,7 @@
               </a:spcAft>
               <a:defRPr sz="950" b="1">
                 <a:solidFill>
-                  <a:srgbClr val="10B981"/>
+                  <a:srgbClr val="059669"/>
                 </a:solidFill>
                 <a:latin typeface="Consolas"/>
               </a:defRPr>
@@ -11352,7 +11472,7 @@
               </a:spcAft>
               <a:defRPr sz="1700" b="1">
                 <a:solidFill>
-                  <a:srgbClr val="FFFFFF"/>
+                  <a:srgbClr val="0F172A"/>
                 </a:solidFill>
                 <a:latin typeface="Segoe UI"/>
               </a:defRPr>
@@ -11365,7 +11485,7 @@
             <a:pPr>
               <a:defRPr sz="1200">
                 <a:solidFill>
-                  <a:srgbClr val="94A3B8"/>
+                  <a:srgbClr val="475569"/>
                 </a:solidFill>
                 <a:latin typeface="Segoe UI"/>
               </a:defRPr>
@@ -11391,11 +11511,11 @@
             <a:avLst/>
           </a:prstGeom>
           <a:solidFill>
-            <a:srgbClr val="0E182C"/>
-          </a:solidFill>
-          <a:ln w="15240">
+            <a:srgbClr val="0F172A"/>
+          </a:solidFill>
+          <a:ln w="12700">
             <a:solidFill>
-              <a:srgbClr val="00E5FF"/>
+              <a:srgbClr val="0F172A"/>
             </a:solidFill>
           </a:ln>
         </p:spPr>
@@ -11436,7 +11556,7 @@
             <a:avLst/>
           </a:prstGeom>
           <a:solidFill>
-            <a:srgbClr val="00E5FF"/>
+            <a:srgbClr val="0284C7"/>
           </a:solidFill>
           <a:ln>
             <a:noFill/>
@@ -11502,13 +11622,13 @@
             <a:pPr>
               <a:defRPr sz="1200" b="1">
                 <a:solidFill>
-                  <a:srgbClr val="00E5FF"/>
+                  <a:srgbClr val="94A3B8"/>
                 </a:solidFill>
                 <a:latin typeface="Consolas"/>
               </a:defRPr>
             </a:pPr>
             <a:r>
-              <a:t>Thank you!  |  Presenter &amp; Architect: R Yaswanth Raju  |  Razorpay AI Buildathon 2026 (Track 3)</a:t>
+              <a:t>Thank you!  |  Presenter &amp; Architect: R Yaswanth Raju  |  Razorpay AI Buildathon (Track 3)</a:t>
             </a:r>
           </a:p>
         </p:txBody>
@@ -11538,13 +11658,13 @@
             <a:pPr>
               <a:defRPr sz="900">
                 <a:solidFill>
-                  <a:srgbClr val="5A6E8C"/>
-                </a:solidFill>
-                <a:latin typeface="Consolas"/>
-              </a:defRPr>
-            </a:pPr>
-            <a:r>
-              <a:t>RecoverIQ  //  AI Revenue Recovery Opportunity Engine  |  Razorpay AI Buildathon (Track 3)  |  Slide 9 of 9</a:t>
+                  <a:srgbClr val="64748B"/>
+                </a:solidFill>
+                <a:latin typeface="Segoe UI"/>
+              </a:defRPr>
+            </a:pPr>
+            <a:r>
+              <a:t>RecoverIQ  |  AI Revenue Recovery Engine  |  Razorpay AI Buildathon  |  Slide 9 of 9</a:t>
             </a:r>
           </a:p>
         </p:txBody>

</xml_diff>